<commit_message>
chore: repoint deck URLs to cpp-statelessness + rebuild both decks
- 9 URL fixes across build-statelessness-pptx.py, build-statelessness-101-pptx.py, sections_statelessness.py
- decks rebuilt: 201 (67 slides), 101 (22 slides), notes on every slide
- build-notes documents both decks
</commit_message>
<xml_diff>
--- a/presentation/cpp-statelessness-101.pptx
+++ b/presentation/cpp-statelessness-101.pptx
@@ -1217,7 +1217,7 @@
           <a:p>
             <a:r>
               <a:rPr sz="1200"/>
-              <a:t>This is the bridge slide back to the bigger picture. Languages with a garbage collector get memory safety for free but don't get deterministic, scope-tied cleanup for free — a connection or a file handle held by a finalizer can linger arbitrarily long after you're done with it. C++ gives up the free memory safety but gets deterministic destruction in exchange, and that's exactly the guarantee request scope needs.</a:t>
+              <a:t>This is the bridge slide back to the bigger picture. Languages with a garbage collector get memory safety automatically but don't get deterministic, scope-tied cleanup — a connection or a file handle held by a finalizer can linger arbitrarily long after you're done with it. C++ trades that automatic memory safety for deterministic destruction, and that's exactly the guarantee request scope needs.</a:t>
             </a:r>
           </a:p>
           <a:p>
@@ -1442,7 +1442,7 @@
           <a:p>
             <a:r>
               <a:rPr sz="1200"/>
-              <a:t>Everything on this slide is a direct extension of something we introduced today, not new material out of nowhere. PMR builds on RAII's acquire-release shape to give request-scoped memory without a per-request heap allocation. Process-scoped ownership builds on the process-scope definition with a concrete pattern for assembling it at startup. State externalization is the full engineering answer to the external-state scope we only named today. And the gRPC capstone shows all three scopes, RAII, PMR, and externalization composed into one real service.</a:t>
+              <a:t>Everything on this slide is a direct extension of something we introduced today, not new material out of nowhere. PMR builds on RAII's acquire-release shape to give request-scoped memory without a per-request heap allocation. Process-scoped ownership builds on the process-scope definition with a concrete pattern for assembling it at startup. State externalization is the full engineering answer to the external-state scope we only named today. And the gRPC end-to-end example shows all three scopes, RAII, PMR, and externalization composed into one real service.</a:t>
             </a:r>
           </a:p>
           <a:p>
@@ -1904,7 +1904,7 @@
           <a:p>
             <a:r>
               <a:rPr sz="1200"/>
-              <a:t>Four framing numbers for the rest of the deck. Any replica answers any request: that's the interchangeability property we're aiming for. Zero coordination to kill one: that's the operational payoff, and it's what the orchestrator is relying on when it reschedules work. Restarts are routine, not incidents: if a restart loses data or breaks a client, that's a design gap, not bad luck. And the last one is the thesis of the whole on-ramp: it's one binary, and whether it's stateless is a property of where it keeps data, not a property you can read off the source code.</a:t>
+              <a:t>Four framing numbers for today's session. Any replica answers any request: that's the interchangeability property we're aiming for. Zero coordination to kill one: that's the operational payoff, and it's what the orchestrator is relying on when it reschedules work. Restarts are routine, not incidents: if a restart loses data or breaks a client, that's a design gap, not bad luck. And the last one is the thesis of the whole on-ramp: it's one binary, and whether it's stateless is a property of where it keeps data, not a property you can read off the source code.</a:t>
             </a:r>
           </a:p>
         </p:txBody>
@@ -5478,7 +5478,7 @@
                 </a:solidFill>
                 <a:latin typeface="Consolas"/>
               </a:rPr>
-              <a:t>github.com/patterncatalyst/cpp-container-optimization-tutorial</a:t>
+              <a:t>github.com/patterncatalyst/cpp-statelessness</a:t>
             </a:r>
           </a:p>
         </p:txBody>
@@ -8824,7 +8824,7 @@
                 </a:solidFill>
                 <a:latin typeface="Calibri"/>
               </a:rPr>
-              <a:t>RAII is why C++ is a genuinely good fit for stateless services, despite having no garbage collector to lean on.</a:t>
+              <a:t>RAII is why C++ is a good fit for stateless services, despite having no garbage collector to lean on.</a:t>
             </a:r>
           </a:p>
         </p:txBody>
@@ -10217,7 +10217,7 @@
                 </a:solidFill>
                 <a:latin typeface="Calibri"/>
               </a:rPr>
-              <a:t>•  The ephemeral filesystem, health checks, graceful shutdown, and a full gRPC capstone that composes all of it</a:t>
+              <a:t>•  The ephemeral filesystem, health checks, graceful shutdown, and a full gRPC end-to-end example that composes all of it</a:t>
             </a:r>
           </a:p>
         </p:txBody>
@@ -10807,7 +10807,7 @@
                 </a:solidFill>
                 <a:latin typeface="Consolas"/>
               </a:rPr>
-              <a:t>github.com/patterncatalyst/cpp-container-optimization-tutorial</a:t>
+              <a:t>github.com/patterncatalyst/cpp-statelessness</a:t>
             </a:r>
           </a:p>
         </p:txBody>

</xml_diff>

<commit_message>
feat: Docker conversion, Red Hat deck house style, hardened Gemfile
- podman -> docker/docker compose across examples, observability, docs, scripts,
  galleries (234 -> ~32 justified 'Podman differs' asides); compose files validate
  under docker compose; 05-threading demo smoke-tested on Docker 29.9
- copied missing test helpers (scripts/lib/_helpers.sh, scripts/cgroup-delegation.sh),
  converted to docker + rootful-aware cgroup logic; repointed demo-05 refs to 05-threading
- diagram 01-deployment-posture.svg: podman-systemd -> docker+systemd
- decks rebranded to lgtm-presentation house style (Red Hat Display/Text/Mono, house red);
  notes on all 89 slides; build-notes merge-writer so decks don't clobber each other
- Gemfile: jekyll ~> 4.3 + webrick + Ruby4 stdlib shims; Gemfile.lock tracked w/ x86_64-linux;
  pages.yml ruby 3.3
- jekyll build exits 0
</commit_message>
<xml_diff>
--- a/presentation/cpp-statelessness-101.pptx
+++ b/presentation/cpp-statelessness-101.pptx
@@ -1448,7 +1448,7 @@
           <a:p>
             <a:r>
               <a:rPr sz="1200"/>
-              <a:t>Read the documents in order if you want the full arc; each one stands alone if you already know roughly where you need depth. Every pattern in the compendium has a runnable Podman demo, host-verified end to end — this on-ramp doesn't carry its own demos, the compendium's do.</a:t>
+              <a:t>Read the documents in order if you want the full arc; each one stands alone if you already know roughly where you need depth. Every pattern in the compendium has a runnable Docker demo, host-verified end to end — this on-ramp doesn't carry its own demos, the compendium's do.</a:t>
             </a:r>
           </a:p>
         </p:txBody>
@@ -5131,7 +5131,7 @@
     <p:bg>
       <p:bgPr>
         <a:solidFill>
-          <a:srgbClr val="1A2B3C"/>
+          <a:srgbClr val="151515"/>
         </a:solidFill>
         <a:effectLst/>
       </p:bgPr>
@@ -5158,7 +5158,7 @@
             <a:avLst/>
           </a:prstGeom>
           <a:solidFill>
-            <a:srgbClr val="27AE60"/>
+            <a:srgbClr val="006E6E"/>
           </a:solidFill>
           <a:ln>
             <a:noFill/>
@@ -5201,7 +5201,7 @@
             <a:avLst/>
           </a:prstGeom>
           <a:solidFill>
-            <a:srgbClr val="00BCD4"/>
+            <a:srgbClr val="EE0000"/>
           </a:solidFill>
           <a:ln>
             <a:noFill/>
@@ -5244,7 +5244,7 @@
             <a:avLst/>
           </a:prstGeom>
           <a:solidFill>
-            <a:srgbClr val="1E6FC8"/>
+            <a:srgbClr val="0066CC"/>
           </a:solidFill>
           <a:ln>
             <a:noFill/>
@@ -5298,9 +5298,9 @@
             <a:r>
               <a:rPr sz="2000" b="1" i="0">
                 <a:solidFill>
-                  <a:srgbClr val="27AE60"/>
-                </a:solidFill>
-                <a:latin typeface="Calibri"/>
+                  <a:srgbClr val="006E6E"/>
+                </a:solidFill>
+                <a:latin typeface="Red Hat Display"/>
               </a:rPr>
               <a:t>STATELESSNESS 101</a:t>
             </a:r>
@@ -5335,7 +5335,7 @@
                 <a:solidFill>
                   <a:srgbClr val="FFFFFF"/>
                 </a:solidFill>
-                <a:latin typeface="Calibri"/>
+                <a:latin typeface="Red Hat Display"/>
               </a:rPr>
               <a:t>A Gentle Start for C++ Services
 Under an Orchestrator</a:t>
@@ -5369,9 +5369,9 @@
             <a:r>
               <a:rPr sz="1600" b="0" i="0">
                 <a:solidFill>
-                  <a:srgbClr val="ECF0F1"/>
-                </a:solidFill>
-                <a:latin typeface="Calibri"/>
+                  <a:srgbClr val="F4F4F4"/>
+                </a:solidFill>
+                <a:latin typeface="Red Hat Text"/>
               </a:rPr>
               <a:t>Why it matters  •  kill / replace / replicate  •  request / process / external scope  •  RAII</a:t>
             </a:r>
@@ -5404,9 +5404,9 @@
             <a:r>
               <a:rPr sz="1400" b="0" i="1">
                 <a:solidFill>
-                  <a:srgbClr val="90A4AE"/>
-                </a:solidFill>
-                <a:latin typeface="Calibri"/>
+                  <a:srgbClr val="8A8A8A"/>
+                </a:solidFill>
+                <a:latin typeface="Red Hat Text"/>
               </a:rPr>
               <a:t>The on-ramp to the Statelessness Compendium — no prior reading required</a:t>
             </a:r>
@@ -5439,9 +5439,9 @@
             <a:r>
               <a:rPr sz="1400" b="0" i="0">
                 <a:solidFill>
-                  <a:srgbClr val="27AE60"/>
-                </a:solidFill>
-                <a:latin typeface="Calibri"/>
+                  <a:srgbClr val="006E6E"/>
+                </a:solidFill>
+                <a:latin typeface="Red Hat Text"/>
               </a:rPr>
               <a:t>Start here if you haven't read the compendium yet</a:t>
             </a:r>
@@ -5474,9 +5474,9 @@
             <a:r>
               <a:rPr sz="1100" b="0" i="0">
                 <a:solidFill>
-                  <a:srgbClr val="90A4AE"/>
-                </a:solidFill>
-                <a:latin typeface="Consolas"/>
+                  <a:srgbClr val="8A8A8A"/>
+                </a:solidFill>
+                <a:latin typeface="Red Hat Mono"/>
               </a:rPr>
               <a:t>github.com/patterncatalyst/cpp-statelessness</a:t>
             </a:r>
@@ -5524,7 +5524,7 @@
             <a:avLst/>
           </a:prstGeom>
           <a:solidFill>
-            <a:srgbClr val="1E6FC8"/>
+            <a:srgbClr val="EE0000"/>
           </a:solidFill>
           <a:ln>
             <a:noFill/>
@@ -5580,7 +5580,7 @@
                 <a:solidFill>
                   <a:srgbClr val="FFFFFF"/>
                 </a:solidFill>
-                <a:latin typeface="Calibri"/>
+                <a:latin typeface="Red Hat Display"/>
               </a:rPr>
               <a:t>Stateless deployment posture: kill, replace, replicate</a:t>
             </a:r>
@@ -5604,7 +5604,7 @@
             </a:avLst>
           </a:prstGeom>
           <a:solidFill>
-            <a:srgbClr val="1A2B3C"/>
+            <a:srgbClr val="151515"/>
           </a:solidFill>
           <a:ln>
             <a:noFill/>
@@ -5660,7 +5660,7 @@
                 <a:solidFill>
                   <a:srgbClr val="FFFFFF"/>
                 </a:solidFill>
-                <a:latin typeface="Calibri"/>
+                <a:latin typeface="Red Hat Display"/>
               </a:rPr>
               <a:t>§2</a:t>
             </a:r>
@@ -5693,11 +5693,11 @@
             <a:r>
               <a:rPr sz="1100" b="0" i="0">
                 <a:solidFill>
-                  <a:srgbClr val="90A4AE"/>
-                </a:solidFill>
-                <a:latin typeface="Calibri"/>
-              </a:rPr>
-              <a:t>Optimizing Modern C++ with Containers   |   Stateless deployment posture: kill, replace, replicate</a:t>
+                  <a:srgbClr val="8A8A8A"/>
+                </a:solidFill>
+                <a:latin typeface="Red Hat Text"/>
+              </a:rPr>
+              <a:t>Stateless C++ Services   |   Stateless deployment posture: kill, replace, replicate</a:t>
             </a:r>
           </a:p>
         </p:txBody>
@@ -5728,9 +5728,9 @@
             <a:r>
               <a:rPr sz="1100" b="0" i="0">
                 <a:solidFill>
-                  <a:srgbClr val="90A4AE"/>
-                </a:solidFill>
-                <a:latin typeface="Calibri"/>
+                  <a:srgbClr val="8A8A8A"/>
+                </a:solidFill>
+                <a:latin typeface="Red Hat Text"/>
               </a:rPr>
               <a:t>10 / 22</a:t>
             </a:r>
@@ -5763,9 +5763,9 @@
             <a:r>
               <a:rPr sz="2800" b="1" i="0">
                 <a:solidFill>
-                  <a:srgbClr val="1A2B3C"/>
-                </a:solidFill>
-                <a:latin typeface="Calibri"/>
+                  <a:srgbClr val="151515"/>
+                </a:solidFill>
+                <a:latin typeface="Red Hat Display"/>
               </a:rPr>
               <a:t>Replicate</a:t>
             </a:r>
@@ -5804,7 +5804,7 @@
                 <a:solidFill>
                   <a:srgbClr val="27AE60"/>
                 </a:solidFill>
-                <a:latin typeface="Calibri"/>
+                <a:latin typeface="Red Hat Text"/>
               </a:rPr>
               <a:t>Many identical copies, one traffic stream</a:t>
             </a:r>
@@ -5820,7 +5820,7 @@
                 <a:solidFill>
                   <a:srgbClr val="1A2B3C"/>
                 </a:solidFill>
-                <a:latin typeface="Calibri"/>
+                <a:latin typeface="Red Hat Text"/>
               </a:rPr>
               <a:t>•  2, 10, or 100 copies of the same process can be serving traffic at once</a:t>
             </a:r>
@@ -5836,7 +5836,7 @@
                 <a:solidFill>
                   <a:srgbClr val="1A2B3C"/>
                 </a:solidFill>
-                <a:latin typeface="Calibri"/>
+                <a:latin typeface="Red Hat Text"/>
               </a:rPr>
               <a:t>•  A load balancer routes each request to whichever replica is free</a:t>
             </a:r>
@@ -5852,7 +5852,7 @@
                 <a:solidFill>
                   <a:srgbClr val="1A2B3C"/>
                 </a:solidFill>
-                <a:latin typeface="Calibri"/>
+                <a:latin typeface="Red Hat Text"/>
               </a:rPr>
               <a:t>•  It does not try to send a user's requests back to "their" replica</a:t>
             </a:r>
@@ -5868,7 +5868,7 @@
                 <a:solidFill>
                   <a:srgbClr val="90A4AE"/>
                 </a:solidFill>
-                <a:latin typeface="Calibri"/>
+                <a:latin typeface="Red Hat Text"/>
               </a:rPr>
               <a:t>This only works if every replica is interchangeable — which is exactly what statelessness means in practice.</a:t>
             </a:r>
@@ -5889,7 +5889,7 @@
     <p:bg>
       <p:bgPr>
         <a:solidFill>
-          <a:srgbClr val="0A1628"/>
+          <a:srgbClr val="AB0000"/>
         </a:solidFill>
         <a:effectLst/>
       </p:bgPr>
@@ -5927,9 +5927,9 @@
             <a:r>
               <a:rPr sz="18000" b="1" i="0">
                 <a:solidFill>
-                  <a:srgbClr val="00BCD4"/>
-                </a:solidFill>
-                <a:latin typeface="Calibri"/>
+                  <a:srgbClr val="EE0000"/>
+                </a:solidFill>
+                <a:latin typeface="Red Hat Display"/>
               </a:rPr>
               <a:t>§3</a:t>
             </a:r>
@@ -5964,7 +5964,7 @@
                 <a:solidFill>
                   <a:srgbClr val="FFFFFF"/>
                 </a:solidFill>
-                <a:latin typeface="Calibri"/>
+                <a:latin typeface="Red Hat Display"/>
               </a:rPr>
               <a:t>Three scopes, briefly</a:t>
             </a:r>
@@ -5997,9 +5997,9 @@
             <a:r>
               <a:rPr sz="2000" b="0" i="1">
                 <a:solidFill>
-                  <a:srgbClr val="90A4AE"/>
-                </a:solidFill>
-                <a:latin typeface="Calibri"/>
+                  <a:srgbClr val="8A8A8A"/>
+                </a:solidFill>
+                <a:latin typeface="Red Hat Text"/>
               </a:rPr>
               <a:t>Not all state is equal; where it lives decides whether a kill is safe.</a:t>
             </a:r>
@@ -6032,9 +6032,9 @@
             <a:r>
               <a:rPr sz="1100" b="0" i="0">
                 <a:solidFill>
-                  <a:srgbClr val="90A4AE"/>
-                </a:solidFill>
-                <a:latin typeface="Calibri"/>
+                  <a:srgbClr val="8A8A8A"/>
+                </a:solidFill>
+                <a:latin typeface="Red Hat Text"/>
               </a:rPr>
               <a:t>11 / 22</a:t>
             </a:r>
@@ -6082,7 +6082,7 @@
             <a:avLst/>
           </a:prstGeom>
           <a:solidFill>
-            <a:srgbClr val="1E6FC8"/>
+            <a:srgbClr val="EE0000"/>
           </a:solidFill>
           <a:ln>
             <a:noFill/>
@@ -6138,7 +6138,7 @@
                 <a:solidFill>
                   <a:srgbClr val="FFFFFF"/>
                 </a:solidFill>
-                <a:latin typeface="Calibri"/>
+                <a:latin typeface="Red Hat Display"/>
               </a:rPr>
               <a:t>Three scopes, briefly</a:t>
             </a:r>
@@ -6162,7 +6162,7 @@
             </a:avLst>
           </a:prstGeom>
           <a:solidFill>
-            <a:srgbClr val="1A2B3C"/>
+            <a:srgbClr val="151515"/>
           </a:solidFill>
           <a:ln>
             <a:noFill/>
@@ -6218,7 +6218,7 @@
                 <a:solidFill>
                   <a:srgbClr val="FFFFFF"/>
                 </a:solidFill>
-                <a:latin typeface="Calibri"/>
+                <a:latin typeface="Red Hat Display"/>
               </a:rPr>
               <a:t>§3</a:t>
             </a:r>
@@ -6251,11 +6251,11 @@
             <a:r>
               <a:rPr sz="1100" b="0" i="0">
                 <a:solidFill>
-                  <a:srgbClr val="90A4AE"/>
-                </a:solidFill>
-                <a:latin typeface="Calibri"/>
-              </a:rPr>
-              <a:t>Optimizing Modern C++ with Containers   |   Three scopes, briefly</a:t>
+                  <a:srgbClr val="8A8A8A"/>
+                </a:solidFill>
+                <a:latin typeface="Red Hat Text"/>
+              </a:rPr>
+              <a:t>Stateless C++ Services   |   Three scopes, briefly</a:t>
             </a:r>
           </a:p>
         </p:txBody>
@@ -6286,9 +6286,9 @@
             <a:r>
               <a:rPr sz="1100" b="0" i="0">
                 <a:solidFill>
-                  <a:srgbClr val="90A4AE"/>
-                </a:solidFill>
-                <a:latin typeface="Calibri"/>
+                  <a:srgbClr val="8A8A8A"/>
+                </a:solidFill>
+                <a:latin typeface="Red Hat Text"/>
               </a:rPr>
               <a:t>12 / 22</a:t>
             </a:r>
@@ -6321,9 +6321,9 @@
             <a:r>
               <a:rPr sz="2800" b="1" i="0">
                 <a:solidFill>
-                  <a:srgbClr val="1A2B3C"/>
-                </a:solidFill>
-                <a:latin typeface="Calibri"/>
+                  <a:srgbClr val="151515"/>
+                </a:solidFill>
+                <a:latin typeface="Red Hat Display"/>
               </a:rPr>
               <a:t>Request scope</a:t>
             </a:r>
@@ -6362,7 +6362,7 @@
                 <a:solidFill>
                   <a:srgbClr val="00BCD4"/>
                 </a:solidFill>
-                <a:latin typeface="Calibri"/>
+                <a:latin typeface="Red Hat Text"/>
               </a:rPr>
               <a:t>Lives for exactly one call</a:t>
             </a:r>
@@ -6378,7 +6378,7 @@
                 <a:solidFill>
                   <a:srgbClr val="1A2B3C"/>
                 </a:solidFill>
-                <a:latin typeface="Calibri"/>
+                <a:latin typeface="Red Hat Text"/>
               </a:rPr>
               <a:t>•  Created when the handler starts, destroyed when it returns</a:t>
             </a:r>
@@ -6394,7 +6394,7 @@
                 <a:solidFill>
                   <a:srgbClr val="1A2B3C"/>
                 </a:solidFill>
-                <a:latin typeface="Calibri"/>
+                <a:latin typeface="Red Hat Text"/>
               </a:rPr>
               <a:t>•  Examples: a parsed request, a per-call buffer, a database transaction handle</a:t>
             </a:r>
@@ -6410,7 +6410,7 @@
                 <a:solidFill>
                   <a:srgbClr val="1A2B3C"/>
                 </a:solidFill>
-                <a:latin typeface="Calibri"/>
+                <a:latin typeface="Red Hat Text"/>
               </a:rPr>
               <a:t>•  Nothing here should be referenced after the response has shipped</a:t>
             </a:r>
@@ -6426,7 +6426,7 @@
                 <a:solidFill>
                   <a:srgbClr val="90A4AE"/>
                 </a:solidFill>
-                <a:latin typeface="Calibri"/>
+                <a:latin typeface="Red Hat Text"/>
               </a:rPr>
               <a:t>If a kill happens mid-request, the one thing in flight is the request itself — and the client can simply retry.</a:t>
             </a:r>
@@ -6474,7 +6474,7 @@
             <a:avLst/>
           </a:prstGeom>
           <a:solidFill>
-            <a:srgbClr val="1E6FC8"/>
+            <a:srgbClr val="EE0000"/>
           </a:solidFill>
           <a:ln>
             <a:noFill/>
@@ -6530,7 +6530,7 @@
                 <a:solidFill>
                   <a:srgbClr val="FFFFFF"/>
                 </a:solidFill>
-                <a:latin typeface="Calibri"/>
+                <a:latin typeface="Red Hat Display"/>
               </a:rPr>
               <a:t>Three scopes, briefly</a:t>
             </a:r>
@@ -6554,7 +6554,7 @@
             </a:avLst>
           </a:prstGeom>
           <a:solidFill>
-            <a:srgbClr val="1A2B3C"/>
+            <a:srgbClr val="151515"/>
           </a:solidFill>
           <a:ln>
             <a:noFill/>
@@ -6610,7 +6610,7 @@
                 <a:solidFill>
                   <a:srgbClr val="FFFFFF"/>
                 </a:solidFill>
-                <a:latin typeface="Calibri"/>
+                <a:latin typeface="Red Hat Display"/>
               </a:rPr>
               <a:t>§3</a:t>
             </a:r>
@@ -6643,11 +6643,11 @@
             <a:r>
               <a:rPr sz="1100" b="0" i="0">
                 <a:solidFill>
-                  <a:srgbClr val="90A4AE"/>
-                </a:solidFill>
-                <a:latin typeface="Calibri"/>
-              </a:rPr>
-              <a:t>Optimizing Modern C++ with Containers   |   Three scopes, briefly</a:t>
+                  <a:srgbClr val="8A8A8A"/>
+                </a:solidFill>
+                <a:latin typeface="Red Hat Text"/>
+              </a:rPr>
+              <a:t>Stateless C++ Services   |   Three scopes, briefly</a:t>
             </a:r>
           </a:p>
         </p:txBody>
@@ -6678,9 +6678,9 @@
             <a:r>
               <a:rPr sz="1100" b="0" i="0">
                 <a:solidFill>
-                  <a:srgbClr val="90A4AE"/>
-                </a:solidFill>
-                <a:latin typeface="Calibri"/>
+                  <a:srgbClr val="8A8A8A"/>
+                </a:solidFill>
+                <a:latin typeface="Red Hat Text"/>
               </a:rPr>
               <a:t>13 / 22</a:t>
             </a:r>
@@ -6713,9 +6713,9 @@
             <a:r>
               <a:rPr sz="2800" b="1" i="0">
                 <a:solidFill>
-                  <a:srgbClr val="1A2B3C"/>
-                </a:solidFill>
-                <a:latin typeface="Calibri"/>
+                  <a:srgbClr val="151515"/>
+                </a:solidFill>
+                <a:latin typeface="Red Hat Display"/>
               </a:rPr>
               <a:t>Process scope</a:t>
             </a:r>
@@ -6754,7 +6754,7 @@
                 <a:solidFill>
                   <a:srgbClr val="1E6FC8"/>
                 </a:solidFill>
-                <a:latin typeface="Calibri"/>
+                <a:latin typeface="Red Hat Text"/>
               </a:rPr>
               <a:t>Lives for as long as the process runs</a:t>
             </a:r>
@@ -6770,7 +6770,7 @@
                 <a:solidFill>
                   <a:srgbClr val="1A2B3C"/>
                 </a:solidFill>
-                <a:latin typeface="Calibri"/>
+                <a:latin typeface="Red Hat Text"/>
               </a:rPr>
               <a:t>•  Examples: a thread pool, a connection pool, parsed configuration</a:t>
             </a:r>
@@ -6786,7 +6786,7 @@
                 <a:solidFill>
                   <a:srgbClr val="1A2B3C"/>
                 </a:solidFill>
-                <a:latin typeface="Calibri"/>
+                <a:latin typeface="Red Hat Text"/>
               </a:rPr>
               <a:t>•  Safe to lose on restart, as long as it's cheaply rebuildable from scratch</a:t>
             </a:r>
@@ -6802,7 +6802,7 @@
                 <a:solidFill>
                   <a:srgbClr val="1A2B3C"/>
                 </a:solidFill>
-                <a:latin typeface="Calibri"/>
+                <a:latin typeface="Red Hat Text"/>
               </a:rPr>
               <a:t>•  Owned explicitly, typically assembled once at startup — not scattered as globals</a:t>
             </a:r>
@@ -6818,7 +6818,7 @@
                 <a:solidFill>
                   <a:srgbClr val="90A4AE"/>
                 </a:solidFill>
-                <a:latin typeface="Calibri"/>
+                <a:latin typeface="Red Hat Text"/>
               </a:rPr>
               <a:t>Losing process-scoped state costs you a restart, nothing more, provided nothing in it was authoritative.</a:t>
             </a:r>
@@ -6866,7 +6866,7 @@
             <a:avLst/>
           </a:prstGeom>
           <a:solidFill>
-            <a:srgbClr val="1E6FC8"/>
+            <a:srgbClr val="EE0000"/>
           </a:solidFill>
           <a:ln>
             <a:noFill/>
@@ -6922,7 +6922,7 @@
                 <a:solidFill>
                   <a:srgbClr val="FFFFFF"/>
                 </a:solidFill>
-                <a:latin typeface="Calibri"/>
+                <a:latin typeface="Red Hat Display"/>
               </a:rPr>
               <a:t>Three scopes, briefly</a:t>
             </a:r>
@@ -6946,7 +6946,7 @@
             </a:avLst>
           </a:prstGeom>
           <a:solidFill>
-            <a:srgbClr val="1A2B3C"/>
+            <a:srgbClr val="151515"/>
           </a:solidFill>
           <a:ln>
             <a:noFill/>
@@ -7002,7 +7002,7 @@
                 <a:solidFill>
                   <a:srgbClr val="FFFFFF"/>
                 </a:solidFill>
-                <a:latin typeface="Calibri"/>
+                <a:latin typeface="Red Hat Display"/>
               </a:rPr>
               <a:t>§3</a:t>
             </a:r>
@@ -7035,11 +7035,11 @@
             <a:r>
               <a:rPr sz="1100" b="0" i="0">
                 <a:solidFill>
-                  <a:srgbClr val="90A4AE"/>
-                </a:solidFill>
-                <a:latin typeface="Calibri"/>
-              </a:rPr>
-              <a:t>Optimizing Modern C++ with Containers   |   Three scopes, briefly</a:t>
+                  <a:srgbClr val="8A8A8A"/>
+                </a:solidFill>
+                <a:latin typeface="Red Hat Text"/>
+              </a:rPr>
+              <a:t>Stateless C++ Services   |   Three scopes, briefly</a:t>
             </a:r>
           </a:p>
         </p:txBody>
@@ -7070,9 +7070,9 @@
             <a:r>
               <a:rPr sz="1100" b="0" i="0">
                 <a:solidFill>
-                  <a:srgbClr val="90A4AE"/>
-                </a:solidFill>
-                <a:latin typeface="Calibri"/>
+                  <a:srgbClr val="8A8A8A"/>
+                </a:solidFill>
+                <a:latin typeface="Red Hat Text"/>
               </a:rPr>
               <a:t>14 / 22</a:t>
             </a:r>
@@ -7105,9 +7105,9 @@
             <a:r>
               <a:rPr sz="2800" b="1" i="0">
                 <a:solidFill>
-                  <a:srgbClr val="1A2B3C"/>
-                </a:solidFill>
-                <a:latin typeface="Calibri"/>
+                  <a:srgbClr val="151515"/>
+                </a:solidFill>
+                <a:latin typeface="Red Hat Display"/>
               </a:rPr>
               <a:t>External state</a:t>
             </a:r>
@@ -7146,7 +7146,7 @@
                 <a:solidFill>
                   <a:srgbClr val="9B59B6"/>
                 </a:solidFill>
-                <a:latin typeface="Calibri"/>
+                <a:latin typeface="Red Hat Text"/>
               </a:rPr>
               <a:t>Lives outside the process entirely</a:t>
             </a:r>
@@ -7162,7 +7162,7 @@
                 <a:solidFill>
                   <a:srgbClr val="1A2B3C"/>
                 </a:solidFill>
-                <a:latin typeface="Calibri"/>
+                <a:latin typeface="Red Hat Text"/>
               </a:rPr>
               <a:t>•  Examples: the database, the cache tier, the message queue</a:t>
             </a:r>
@@ -7178,7 +7178,7 @@
                 <a:solidFill>
                   <a:srgbClr val="1A2B3C"/>
                 </a:solidFill>
-                <a:latin typeface="Calibri"/>
+                <a:latin typeface="Red Hat Text"/>
               </a:rPr>
               <a:t>•  The only place authoritative data is allowed to live</a:t>
             </a:r>
@@ -7194,7 +7194,7 @@
                 <a:solidFill>
                   <a:srgbClr val="1A2B3C"/>
                 </a:solidFill>
-                <a:latin typeface="Calibri"/>
+                <a:latin typeface="Red Hat Text"/>
               </a:rPr>
               <a:t>•  Reached over the network, with its own availability and consistency story</a:t>
             </a:r>
@@ -7210,7 +7210,7 @@
                 <a:solidFill>
                   <a:srgbClr val="90A4AE"/>
                 </a:solidFill>
-                <a:latin typeface="Calibri"/>
+                <a:latin typeface="Red Hat Text"/>
               </a:rPr>
               <a:t>The compendium calls this deploy-time scope and spends a full document on reaching it safely — pools, idempotency, the outbox pattern.</a:t>
             </a:r>
@@ -7231,7 +7231,7 @@
     <p:bg>
       <p:bgPr>
         <a:solidFill>
-          <a:srgbClr val="0A1628"/>
+          <a:srgbClr val="AB0000"/>
         </a:solidFill>
         <a:effectLst/>
       </p:bgPr>
@@ -7269,9 +7269,9 @@
             <a:r>
               <a:rPr sz="18000" b="1" i="0">
                 <a:solidFill>
-                  <a:srgbClr val="00BCD4"/>
-                </a:solidFill>
-                <a:latin typeface="Calibri"/>
+                  <a:srgbClr val="EE0000"/>
+                </a:solidFill>
+                <a:latin typeface="Red Hat Display"/>
               </a:rPr>
               <a:t>§4</a:t>
             </a:r>
@@ -7306,7 +7306,7 @@
                 <a:solidFill>
                   <a:srgbClr val="FFFFFF"/>
                 </a:solidFill>
-                <a:latin typeface="Calibri"/>
+                <a:latin typeface="Red Hat Display"/>
               </a:rPr>
               <a:t>RAII: the mechanism</a:t>
             </a:r>
@@ -7339,9 +7339,9 @@
             <a:r>
               <a:rPr sz="2000" b="0" i="1">
                 <a:solidFill>
-                  <a:srgbClr val="90A4AE"/>
-                </a:solidFill>
-                <a:latin typeface="Calibri"/>
+                  <a:srgbClr val="8A8A8A"/>
+                </a:solidFill>
+                <a:latin typeface="Red Hat Text"/>
               </a:rPr>
               <a:t>A destructor that always runs is how C++ makes request scope a guarantee instead of a convention.</a:t>
             </a:r>
@@ -7374,9 +7374,9 @@
             <a:r>
               <a:rPr sz="1100" b="0" i="0">
                 <a:solidFill>
-                  <a:srgbClr val="90A4AE"/>
-                </a:solidFill>
-                <a:latin typeface="Calibri"/>
+                  <a:srgbClr val="8A8A8A"/>
+                </a:solidFill>
+                <a:latin typeface="Red Hat Text"/>
               </a:rPr>
               <a:t>15 / 22</a:t>
             </a:r>
@@ -7424,7 +7424,7 @@
             <a:avLst/>
           </a:prstGeom>
           <a:solidFill>
-            <a:srgbClr val="1E6FC8"/>
+            <a:srgbClr val="EE0000"/>
           </a:solidFill>
           <a:ln>
             <a:noFill/>
@@ -7480,7 +7480,7 @@
                 <a:solidFill>
                   <a:srgbClr val="FFFFFF"/>
                 </a:solidFill>
-                <a:latin typeface="Calibri"/>
+                <a:latin typeface="Red Hat Display"/>
               </a:rPr>
               <a:t>RAII: the mechanism</a:t>
             </a:r>
@@ -7504,7 +7504,7 @@
             </a:avLst>
           </a:prstGeom>
           <a:solidFill>
-            <a:srgbClr val="1A2B3C"/>
+            <a:srgbClr val="151515"/>
           </a:solidFill>
           <a:ln>
             <a:noFill/>
@@ -7560,7 +7560,7 @@
                 <a:solidFill>
                   <a:srgbClr val="FFFFFF"/>
                 </a:solidFill>
-                <a:latin typeface="Calibri"/>
+                <a:latin typeface="Red Hat Display"/>
               </a:rPr>
               <a:t>§4</a:t>
             </a:r>
@@ -7593,11 +7593,11 @@
             <a:r>
               <a:rPr sz="1100" b="0" i="0">
                 <a:solidFill>
-                  <a:srgbClr val="90A4AE"/>
-                </a:solidFill>
-                <a:latin typeface="Calibri"/>
-              </a:rPr>
-              <a:t>Optimizing Modern C++ with Containers   |   RAII: the mechanism</a:t>
+                  <a:srgbClr val="8A8A8A"/>
+                </a:solidFill>
+                <a:latin typeface="Red Hat Text"/>
+              </a:rPr>
+              <a:t>Stateless C++ Services   |   RAII: the mechanism</a:t>
             </a:r>
           </a:p>
         </p:txBody>
@@ -7628,9 +7628,9 @@
             <a:r>
               <a:rPr sz="1100" b="0" i="0">
                 <a:solidFill>
-                  <a:srgbClr val="90A4AE"/>
-                </a:solidFill>
-                <a:latin typeface="Calibri"/>
+                  <a:srgbClr val="8A8A8A"/>
+                </a:solidFill>
+                <a:latin typeface="Red Hat Text"/>
               </a:rPr>
               <a:t>16 / 22</a:t>
             </a:r>
@@ -7663,9 +7663,9 @@
             <a:r>
               <a:rPr sz="2800" b="1" i="0">
                 <a:solidFill>
-                  <a:srgbClr val="1A2B3C"/>
-                </a:solidFill>
-                <a:latin typeface="Calibri"/>
+                  <a:srgbClr val="151515"/>
+                </a:solidFill>
+                <a:latin typeface="Red Hat Display"/>
               </a:rPr>
               <a:t>What RAII actually buys you</a:t>
             </a:r>
@@ -7704,7 +7704,7 @@
                 <a:solidFill>
                   <a:srgbClr val="27AE60"/>
                 </a:solidFill>
-                <a:latin typeface="Calibri"/>
+                <a:latin typeface="Red Hat Text"/>
               </a:rPr>
               <a:t>Bind a resource's lifetime to an object's scope</a:t>
             </a:r>
@@ -7720,7 +7720,7 @@
                 <a:solidFill>
                   <a:srgbClr val="1A2B3C"/>
                 </a:solidFill>
-                <a:latin typeface="Calibri"/>
+                <a:latin typeface="Red Hat Text"/>
               </a:rPr>
               <a:t>•  Acquire the resource in the constructor</a:t>
             </a:r>
@@ -7736,7 +7736,7 @@
                 <a:solidFill>
                   <a:srgbClr val="1A2B3C"/>
                 </a:solidFill>
-                <a:latin typeface="Calibri"/>
+                <a:latin typeface="Red Hat Text"/>
               </a:rPr>
               <a:t>•  Release it in the destructor</a:t>
             </a:r>
@@ -7752,7 +7752,7 @@
                 <a:solidFill>
                   <a:srgbClr val="1A2B3C"/>
                 </a:solidFill>
-                <a:latin typeface="Calibri"/>
+                <a:latin typeface="Red Hat Text"/>
               </a:rPr>
               <a:t>•  The compiler calls that destructor on every exit path — return, break, or an exception</a:t>
             </a:r>
@@ -7768,7 +7768,7 @@
                 <a:solidFill>
                   <a:srgbClr val="90A4AE"/>
                 </a:solidFill>
-                <a:latin typeface="Calibri"/>
+                <a:latin typeface="Red Hat Text"/>
               </a:rPr>
               <a:t>You don't write cleanup code at each exit point. You write it once, and the language guarantees it runs.</a:t>
             </a:r>
@@ -7816,7 +7816,7 @@
             <a:avLst/>
           </a:prstGeom>
           <a:solidFill>
-            <a:srgbClr val="1E6FC8"/>
+            <a:srgbClr val="EE0000"/>
           </a:solidFill>
           <a:ln>
             <a:noFill/>
@@ -7872,7 +7872,7 @@
                 <a:solidFill>
                   <a:srgbClr val="FFFFFF"/>
                 </a:solidFill>
-                <a:latin typeface="Calibri"/>
+                <a:latin typeface="Red Hat Display"/>
               </a:rPr>
               <a:t>RAII: the mechanism</a:t>
             </a:r>
@@ -7896,7 +7896,7 @@
             </a:avLst>
           </a:prstGeom>
           <a:solidFill>
-            <a:srgbClr val="1A2B3C"/>
+            <a:srgbClr val="151515"/>
           </a:solidFill>
           <a:ln>
             <a:noFill/>
@@ -7952,7 +7952,7 @@
                 <a:solidFill>
                   <a:srgbClr val="FFFFFF"/>
                 </a:solidFill>
-                <a:latin typeface="Calibri"/>
+                <a:latin typeface="Red Hat Display"/>
               </a:rPr>
               <a:t>§4</a:t>
             </a:r>
@@ -7985,11 +7985,11 @@
             <a:r>
               <a:rPr sz="1100" b="0" i="0">
                 <a:solidFill>
-                  <a:srgbClr val="90A4AE"/>
-                </a:solidFill>
-                <a:latin typeface="Calibri"/>
-              </a:rPr>
-              <a:t>Optimizing Modern C++ with Containers   |   RAII: the mechanism</a:t>
+                  <a:srgbClr val="8A8A8A"/>
+                </a:solidFill>
+                <a:latin typeface="Red Hat Text"/>
+              </a:rPr>
+              <a:t>Stateless C++ Services   |   RAII: the mechanism</a:t>
             </a:r>
           </a:p>
         </p:txBody>
@@ -8020,9 +8020,9 @@
             <a:r>
               <a:rPr sz="1100" b="0" i="0">
                 <a:solidFill>
-                  <a:srgbClr val="90A4AE"/>
-                </a:solidFill>
-                <a:latin typeface="Calibri"/>
+                  <a:srgbClr val="8A8A8A"/>
+                </a:solidFill>
+                <a:latin typeface="Red Hat Text"/>
               </a:rPr>
               <a:t>17 / 22</a:t>
             </a:r>
@@ -8055,9 +8055,9 @@
             <a:r>
               <a:rPr sz="2800" b="1" i="0">
                 <a:solidFill>
-                  <a:srgbClr val="1A2B3C"/>
-                </a:solidFill>
-                <a:latin typeface="Calibri"/>
+                  <a:srgbClr val="151515"/>
+                </a:solidFill>
+                <a:latin typeface="Red Hat Display"/>
               </a:rPr>
               <a:t>A request-scoped object, start to finish</a:t>
             </a:r>
@@ -8096,7 +8096,7 @@
                 <a:solidFill>
                   <a:srgbClr val="1E6FC8"/>
                 </a:solidFill>
-                <a:latin typeface="Calibri"/>
+                <a:latin typeface="Red Hat Text"/>
               </a:rPr>
               <a:t>The shape you'll see throughout the compendium</a:t>
             </a:r>
@@ -8112,7 +8112,7 @@
                 <a:solidFill>
                   <a:srgbClr val="1A2B3C"/>
                 </a:solidFill>
-                <a:latin typeface="Calibri"/>
+                <a:latin typeface="Red Hat Text"/>
               </a:rPr>
               <a:t>•  The pooled connection is acquired once, in the constructor</a:t>
             </a:r>
@@ -8128,7 +8128,7 @@
                 <a:solidFill>
                   <a:srgbClr val="1A2B3C"/>
                 </a:solidFill>
-                <a:latin typeface="Calibri"/>
+                <a:latin typeface="Red Hat Text"/>
               </a:rPr>
               <a:t>•  Every exit from handle() destroys ctx — success, early return, or exception</a:t>
             </a:r>
@@ -8144,7 +8144,7 @@
                 <a:solidFill>
                   <a:srgbClr val="1A2B3C"/>
                 </a:solidFill>
-                <a:latin typeface="Calibri"/>
+                <a:latin typeface="Red Hat Text"/>
               </a:rPr>
               <a:t>•  The connection returns to the pool exactly once, no matter which path was taken</a:t>
             </a:r>
@@ -8166,7 +8166,7 @@
             <a:avLst/>
           </a:prstGeom>
           <a:solidFill>
-            <a:srgbClr val="0D2137"/>
+            <a:srgbClr val="151515"/>
           </a:solidFill>
           <a:ln>
             <a:noFill/>
@@ -8219,9 +8219,9 @@
             <a:r>
               <a:rPr sz="1200">
                 <a:solidFill>
-                  <a:srgbClr val="ECF0F1"/>
-                </a:solidFill>
-                <a:latin typeface="Consolas"/>
+                  <a:srgbClr val="F4F4F4"/>
+                </a:solidFill>
+                <a:latin typeface="Red Hat Mono"/>
               </a:rPr>
               <a:t>class RequestContext {</a:t>
             </a:r>
@@ -8230,9 +8230,9 @@
             <a:r>
               <a:rPr sz="1200">
                 <a:solidFill>
-                  <a:srgbClr val="ECF0F1"/>
-                </a:solidFill>
-                <a:latin typeface="Consolas"/>
+                  <a:srgbClr val="F4F4F4"/>
+                </a:solidFill>
+                <a:latin typeface="Red Hat Mono"/>
               </a:rPr>
               <a:t>public:</a:t>
             </a:r>
@@ -8241,9 +8241,9 @@
             <a:r>
               <a:rPr sz="1200">
                 <a:solidFill>
-                  <a:srgbClr val="ECF0F1"/>
-                </a:solidFill>
-                <a:latin typeface="Consolas"/>
+                  <a:srgbClr val="F4F4F4"/>
+                </a:solidFill>
+                <a:latin typeface="Red Hat Mono"/>
               </a:rPr>
               <a:t>    explicit RequestContext(ConnectionPool&amp; pool)</a:t>
             </a:r>
@@ -8252,9 +8252,9 @@
             <a:r>
               <a:rPr sz="1200">
                 <a:solidFill>
-                  <a:srgbClr val="ECF0F1"/>
-                </a:solidFill>
-                <a:latin typeface="Consolas"/>
+                  <a:srgbClr val="F4F4F4"/>
+                </a:solidFill>
+                <a:latin typeface="Red Hat Mono"/>
               </a:rPr>
               <a:t>        : conn_(pool.acquire()) {}</a:t>
             </a:r>
@@ -8263,9 +8263,9 @@
             <a:r>
               <a:rPr sz="1200">
                 <a:solidFill>
-                  <a:srgbClr val="ECF0F1"/>
-                </a:solidFill>
-                <a:latin typeface="Consolas"/>
+                  <a:srgbClr val="F4F4F4"/>
+                </a:solidFill>
+                <a:latin typeface="Red Hat Mono"/>
               </a:rPr>
               <a:t> </a:t>
             </a:r>
@@ -8274,9 +8274,9 @@
             <a:r>
               <a:rPr sz="1200">
                 <a:solidFill>
-                  <a:srgbClr val="ECF0F1"/>
-                </a:solidFill>
-                <a:latin typeface="Consolas"/>
+                  <a:srgbClr val="F4F4F4"/>
+                </a:solidFill>
+                <a:latin typeface="Red Hat Mono"/>
               </a:rPr>
               <a:t>    Connection&amp; conn() { return conn_; }</a:t>
             </a:r>
@@ -8285,9 +8285,9 @@
             <a:r>
               <a:rPr sz="1200">
                 <a:solidFill>
-                  <a:srgbClr val="ECF0F1"/>
-                </a:solidFill>
-                <a:latin typeface="Consolas"/>
+                  <a:srgbClr val="F4F4F4"/>
+                </a:solidFill>
+                <a:latin typeface="Red Hat Mono"/>
               </a:rPr>
               <a:t> </a:t>
             </a:r>
@@ -8296,9 +8296,9 @@
             <a:r>
               <a:rPr sz="1200">
                 <a:solidFill>
-                  <a:srgbClr val="ECF0F1"/>
-                </a:solidFill>
-                <a:latin typeface="Consolas"/>
+                  <a:srgbClr val="F4F4F4"/>
+                </a:solidFill>
+                <a:latin typeface="Red Hat Mono"/>
               </a:rPr>
               <a:t>private:</a:t>
             </a:r>
@@ -8307,9 +8307,9 @@
             <a:r>
               <a:rPr sz="1200">
                 <a:solidFill>
-                  <a:srgbClr val="ECF0F1"/>
-                </a:solidFill>
-                <a:latin typeface="Consolas"/>
+                  <a:srgbClr val="F4F4F4"/>
+                </a:solidFill>
+                <a:latin typeface="Red Hat Mono"/>
               </a:rPr>
               <a:t>    PooledConnection conn_;  // returns to the pool</a:t>
             </a:r>
@@ -8318,9 +8318,9 @@
             <a:r>
               <a:rPr sz="1200">
                 <a:solidFill>
-                  <a:srgbClr val="ECF0F1"/>
-                </a:solidFill>
-                <a:latin typeface="Consolas"/>
+                  <a:srgbClr val="F4F4F4"/>
+                </a:solidFill>
+                <a:latin typeface="Red Hat Mono"/>
               </a:rPr>
               <a:t>                             // when this is destroyed</a:t>
             </a:r>
@@ -8329,9 +8329,9 @@
             <a:r>
               <a:rPr sz="1200">
                 <a:solidFill>
-                  <a:srgbClr val="ECF0F1"/>
-                </a:solidFill>
-                <a:latin typeface="Consolas"/>
+                  <a:srgbClr val="F4F4F4"/>
+                </a:solidFill>
+                <a:latin typeface="Red Hat Mono"/>
               </a:rPr>
               <a:t>};</a:t>
             </a:r>
@@ -8340,9 +8340,9 @@
             <a:r>
               <a:rPr sz="1200">
                 <a:solidFill>
-                  <a:srgbClr val="ECF0F1"/>
-                </a:solidFill>
-                <a:latin typeface="Consolas"/>
+                  <a:srgbClr val="F4F4F4"/>
+                </a:solidFill>
+                <a:latin typeface="Red Hat Mono"/>
               </a:rPr>
               <a:t> </a:t>
             </a:r>
@@ -8351,9 +8351,9 @@
             <a:r>
               <a:rPr sz="1200">
                 <a:solidFill>
-                  <a:srgbClr val="ECF0F1"/>
-                </a:solidFill>
-                <a:latin typeface="Consolas"/>
+                  <a:srgbClr val="F4F4F4"/>
+                </a:solidFill>
+                <a:latin typeface="Red Hat Mono"/>
               </a:rPr>
               <a:t>void handle(ConnectionPool&amp; pool, const Request&amp; req) {</a:t>
             </a:r>
@@ -8362,9 +8362,9 @@
             <a:r>
               <a:rPr sz="1200">
                 <a:solidFill>
-                  <a:srgbClr val="ECF0F1"/>
-                </a:solidFill>
-                <a:latin typeface="Consolas"/>
+                  <a:srgbClr val="F4F4F4"/>
+                </a:solidFill>
+                <a:latin typeface="Red Hat Mono"/>
               </a:rPr>
               <a:t>    RequestContext ctx(pool);</a:t>
             </a:r>
@@ -8373,9 +8373,9 @@
             <a:r>
               <a:rPr sz="1200">
                 <a:solidFill>
-                  <a:srgbClr val="ECF0F1"/>
-                </a:solidFill>
-                <a:latin typeface="Consolas"/>
+                  <a:srgbClr val="F4F4F4"/>
+                </a:solidFill>
+                <a:latin typeface="Red Hat Mono"/>
               </a:rPr>
               <a:t> </a:t>
             </a:r>
@@ -8384,9 +8384,9 @@
             <a:r>
               <a:rPr sz="1200">
                 <a:solidFill>
-                  <a:srgbClr val="ECF0F1"/>
-                </a:solidFill>
-                <a:latin typeface="Consolas"/>
+                  <a:srgbClr val="F4F4F4"/>
+                </a:solidFill>
+                <a:latin typeface="Red Hat Mono"/>
               </a:rPr>
               <a:t>    if (!valid(req)) return;        // ctx destructs here</a:t>
             </a:r>
@@ -8395,9 +8395,9 @@
             <a:r>
               <a:rPr sz="1200">
                 <a:solidFill>
-                  <a:srgbClr val="ECF0F1"/>
-                </a:solidFill>
-                <a:latin typeface="Consolas"/>
+                  <a:srgbClr val="F4F4F4"/>
+                </a:solidFill>
+                <a:latin typeface="Red Hat Mono"/>
               </a:rPr>
               <a:t>    ctx.conn().execute(build(req));  // might throw</a:t>
             </a:r>
@@ -8406,9 +8406,9 @@
             <a:r>
               <a:rPr sz="1200">
                 <a:solidFill>
-                  <a:srgbClr val="ECF0F1"/>
-                </a:solidFill>
-                <a:latin typeface="Consolas"/>
+                  <a:srgbClr val="F4F4F4"/>
+                </a:solidFill>
+                <a:latin typeface="Red Hat Mono"/>
               </a:rPr>
               <a:t> </a:t>
             </a:r>
@@ -8417,9 +8417,9 @@
             <a:r>
               <a:rPr sz="1200">
                 <a:solidFill>
-                  <a:srgbClr val="ECF0F1"/>
-                </a:solidFill>
-                <a:latin typeface="Consolas"/>
+                  <a:srgbClr val="F4F4F4"/>
+                </a:solidFill>
+                <a:latin typeface="Red Hat Mono"/>
               </a:rPr>
               <a:t>}  // ... or ctx destructs here, on the normal path</a:t>
             </a:r>
@@ -8428,9 +8428,9 @@
             <a:r>
               <a:rPr sz="1200">
                 <a:solidFill>
-                  <a:srgbClr val="ECF0F1"/>
-                </a:solidFill>
-                <a:latin typeface="Consolas"/>
+                  <a:srgbClr val="F4F4F4"/>
+                </a:solidFill>
+                <a:latin typeface="Red Hat Mono"/>
               </a:rPr>
               <a:t> </a:t>
             </a:r>
@@ -8478,7 +8478,7 @@
             <a:avLst/>
           </a:prstGeom>
           <a:solidFill>
-            <a:srgbClr val="1E6FC8"/>
+            <a:srgbClr val="EE0000"/>
           </a:solidFill>
           <a:ln>
             <a:noFill/>
@@ -8534,7 +8534,7 @@
                 <a:solidFill>
                   <a:srgbClr val="FFFFFF"/>
                 </a:solidFill>
-                <a:latin typeface="Calibri"/>
+                <a:latin typeface="Red Hat Display"/>
               </a:rPr>
               <a:t>RAII: the mechanism</a:t>
             </a:r>
@@ -8558,7 +8558,7 @@
             </a:avLst>
           </a:prstGeom>
           <a:solidFill>
-            <a:srgbClr val="1A2B3C"/>
+            <a:srgbClr val="151515"/>
           </a:solidFill>
           <a:ln>
             <a:noFill/>
@@ -8614,7 +8614,7 @@
                 <a:solidFill>
                   <a:srgbClr val="FFFFFF"/>
                 </a:solidFill>
-                <a:latin typeface="Calibri"/>
+                <a:latin typeface="Red Hat Display"/>
               </a:rPr>
               <a:t>§4</a:t>
             </a:r>
@@ -8647,11 +8647,11 @@
             <a:r>
               <a:rPr sz="1100" b="0" i="0">
                 <a:solidFill>
-                  <a:srgbClr val="90A4AE"/>
-                </a:solidFill>
-                <a:latin typeface="Calibri"/>
-              </a:rPr>
-              <a:t>Optimizing Modern C++ with Containers   |   RAII: the mechanism</a:t>
+                  <a:srgbClr val="8A8A8A"/>
+                </a:solidFill>
+                <a:latin typeface="Red Hat Text"/>
+              </a:rPr>
+              <a:t>Stateless C++ Services   |   RAII: the mechanism</a:t>
             </a:r>
           </a:p>
         </p:txBody>
@@ -8682,9 +8682,9 @@
             <a:r>
               <a:rPr sz="1100" b="0" i="0">
                 <a:solidFill>
-                  <a:srgbClr val="90A4AE"/>
-                </a:solidFill>
-                <a:latin typeface="Calibri"/>
+                  <a:srgbClr val="8A8A8A"/>
+                </a:solidFill>
+                <a:latin typeface="Red Hat Text"/>
               </a:rPr>
               <a:t>18 / 22</a:t>
             </a:r>
@@ -8717,9 +8717,9 @@
             <a:r>
               <a:rPr sz="2800" b="1" i="0">
                 <a:solidFill>
-                  <a:srgbClr val="1A2B3C"/>
-                </a:solidFill>
-                <a:latin typeface="Calibri"/>
+                  <a:srgbClr val="151515"/>
+                </a:solidFill>
+                <a:latin typeface="Red Hat Display"/>
               </a:rPr>
               <a:t>Why this is the mechanism, not just a style</a:t>
             </a:r>
@@ -8758,7 +8758,7 @@
                 <a:solidFill>
                   <a:srgbClr val="E84855"/>
                 </a:solidFill>
-                <a:latin typeface="Calibri"/>
+                <a:latin typeface="Red Hat Text"/>
               </a:rPr>
               <a:t>Enforceable beats aspirational</a:t>
             </a:r>
@@ -8774,7 +8774,7 @@
                 <a:solidFill>
                   <a:srgbClr val="1A2B3C"/>
                 </a:solidFill>
-                <a:latin typeface="Calibri"/>
+                <a:latin typeface="Red Hat Text"/>
               </a:rPr>
               <a:t>•  A naming convention or a code-review checklist can be skipped under deadline pressure</a:t>
             </a:r>
@@ -8790,7 +8790,7 @@
                 <a:solidFill>
                   <a:srgbClr val="1A2B3C"/>
                 </a:solidFill>
-                <a:latin typeface="Calibri"/>
+                <a:latin typeface="Red Hat Text"/>
               </a:rPr>
               <a:t>•  A destructor that the compiler calls on every path cannot be skipped</a:t>
             </a:r>
@@ -8806,7 +8806,7 @@
                 <a:solidFill>
                   <a:srgbClr val="1A2B3C"/>
                 </a:solidFill>
-                <a:latin typeface="Calibri"/>
+                <a:latin typeface="Red Hat Text"/>
               </a:rPr>
               <a:t>•  This is what makes "nothing outlives the request" a property you can rely on, not a hope</a:t>
             </a:r>
@@ -8822,7 +8822,7 @@
                 <a:solidFill>
                   <a:srgbClr val="90A4AE"/>
                 </a:solidFill>
-                <a:latin typeface="Calibri"/>
+                <a:latin typeface="Red Hat Text"/>
               </a:rPr>
               <a:t>RAII is why C++ is a good fit for stateless services, despite having no garbage collector to lean on.</a:t>
             </a:r>
@@ -8843,7 +8843,7 @@
     <p:bg>
       <p:bgPr>
         <a:solidFill>
-          <a:srgbClr val="0A1628"/>
+          <a:srgbClr val="AB0000"/>
         </a:solidFill>
         <a:effectLst/>
       </p:bgPr>
@@ -8881,9 +8881,9 @@
             <a:r>
               <a:rPr sz="18000" b="1" i="0">
                 <a:solidFill>
-                  <a:srgbClr val="00BCD4"/>
-                </a:solidFill>
-                <a:latin typeface="Calibri"/>
+                  <a:srgbClr val="EE0000"/>
+                </a:solidFill>
+                <a:latin typeface="Red Hat Display"/>
               </a:rPr>
               <a:t>§5</a:t>
             </a:r>
@@ -8918,7 +8918,7 @@
                 <a:solidFill>
                   <a:srgbClr val="FFFFFF"/>
                 </a:solidFill>
-                <a:latin typeface="Calibri"/>
+                <a:latin typeface="Red Hat Display"/>
               </a:rPr>
               <a:t>Where the compendium goes deeper</a:t>
             </a:r>
@@ -8951,9 +8951,9 @@
             <a:r>
               <a:rPr sz="2000" b="0" i="1">
                 <a:solidFill>
-                  <a:srgbClr val="90A4AE"/>
-                </a:solidFill>
-                <a:latin typeface="Calibri"/>
+                  <a:srgbClr val="8A8A8A"/>
+                </a:solidFill>
+                <a:latin typeface="Red Hat Text"/>
               </a:rPr>
               <a:t>This was the on-ramp. Eleven documents build the rest of the machine.</a:t>
             </a:r>
@@ -8986,9 +8986,9 @@
             <a:r>
               <a:rPr sz="1100" b="0" i="0">
                 <a:solidFill>
-                  <a:srgbClr val="90A4AE"/>
-                </a:solidFill>
-                <a:latin typeface="Calibri"/>
+                  <a:srgbClr val="8A8A8A"/>
+                </a:solidFill>
+                <a:latin typeface="Red Hat Text"/>
               </a:rPr>
               <a:t>19 / 22</a:t>
             </a:r>
@@ -9036,7 +9036,7 @@
             <a:avLst/>
           </a:prstGeom>
           <a:solidFill>
-            <a:srgbClr val="1E6FC8"/>
+            <a:srgbClr val="EE0000"/>
           </a:solidFill>
           <a:ln>
             <a:noFill/>
@@ -9092,7 +9092,7 @@
                 <a:solidFill>
                   <a:srgbClr val="FFFFFF"/>
                 </a:solidFill>
-                <a:latin typeface="Calibri"/>
+                <a:latin typeface="Red Hat Display"/>
               </a:rPr>
               <a:t>Agenda — the on-ramp</a:t>
             </a:r>
@@ -9116,7 +9116,7 @@
             </a:avLst>
           </a:prstGeom>
           <a:solidFill>
-            <a:srgbClr val="1A2B3C"/>
+            <a:srgbClr val="151515"/>
           </a:solidFill>
           <a:ln>
             <a:noFill/>
@@ -9172,7 +9172,7 @@
                 <a:solidFill>
                   <a:srgbClr val="FFFFFF"/>
                 </a:solidFill>
-                <a:latin typeface="Calibri"/>
+                <a:latin typeface="Red Hat Display"/>
               </a:rPr>
               <a:t>Overview</a:t>
             </a:r>
@@ -9205,11 +9205,11 @@
             <a:r>
               <a:rPr sz="1100" b="0" i="0">
                 <a:solidFill>
-                  <a:srgbClr val="90A4AE"/>
-                </a:solidFill>
-                <a:latin typeface="Calibri"/>
-              </a:rPr>
-              <a:t>Optimizing Modern C++ with Containers   |   Agenda</a:t>
+                  <a:srgbClr val="8A8A8A"/>
+                </a:solidFill>
+                <a:latin typeface="Red Hat Text"/>
+              </a:rPr>
+              <a:t>Stateless C++ Services   |   Agenda</a:t>
             </a:r>
           </a:p>
         </p:txBody>
@@ -9240,9 +9240,9 @@
             <a:r>
               <a:rPr sz="1100" b="0" i="0">
                 <a:solidFill>
-                  <a:srgbClr val="90A4AE"/>
-                </a:solidFill>
-                <a:latin typeface="Calibri"/>
+                  <a:srgbClr val="8A8A8A"/>
+                </a:solidFill>
+                <a:latin typeface="Red Hat Text"/>
               </a:rPr>
               <a:t>2 / 22</a:t>
             </a:r>
@@ -9264,7 +9264,7 @@
             <a:avLst/>
           </a:prstGeom>
           <a:solidFill>
-            <a:srgbClr val="E84855"/>
+            <a:srgbClr val="B71C1C"/>
           </a:solidFill>
           <a:ln>
             <a:noFill/>
@@ -9320,7 +9320,7 @@
                 <a:solidFill>
                   <a:srgbClr val="FFFFFF"/>
                 </a:solidFill>
-                <a:latin typeface="Calibri"/>
+                <a:latin typeface="Red Hat Display"/>
               </a:rPr>
               <a:t>1</a:t>
             </a:r>
@@ -9353,9 +9353,9 @@
             <a:r>
               <a:rPr sz="1500" b="0" i="0">
                 <a:solidFill>
-                  <a:srgbClr val="1A2B3C"/>
-                </a:solidFill>
-                <a:latin typeface="Calibri"/>
+                  <a:srgbClr val="151515"/>
+                </a:solidFill>
+                <a:latin typeface="Red Hat Text"/>
               </a:rPr>
               <a:t>Why statelessness matters for C++ services</a:t>
             </a:r>
@@ -9377,7 +9377,7 @@
             <a:avLst/>
           </a:prstGeom>
           <a:solidFill>
-            <a:srgbClr val="F5A623"/>
+            <a:srgbClr val="B36B00"/>
           </a:solidFill>
           <a:ln>
             <a:noFill/>
@@ -9433,7 +9433,7 @@
                 <a:solidFill>
                   <a:srgbClr val="FFFFFF"/>
                 </a:solidFill>
-                <a:latin typeface="Calibri"/>
+                <a:latin typeface="Red Hat Display"/>
               </a:rPr>
               <a:t>2</a:t>
             </a:r>
@@ -9466,9 +9466,9 @@
             <a:r>
               <a:rPr sz="1500" b="0" i="0">
                 <a:solidFill>
-                  <a:srgbClr val="1A2B3C"/>
-                </a:solidFill>
-                <a:latin typeface="Calibri"/>
+                  <a:srgbClr val="151515"/>
+                </a:solidFill>
+                <a:latin typeface="Red Hat Text"/>
               </a:rPr>
               <a:t>Stateless deployment posture: kill, replace, replicate</a:t>
             </a:r>
@@ -9490,7 +9490,7 @@
             <a:avLst/>
           </a:prstGeom>
           <a:solidFill>
-            <a:srgbClr val="1E6FC8"/>
+            <a:srgbClr val="0066CC"/>
           </a:solidFill>
           <a:ln>
             <a:noFill/>
@@ -9546,7 +9546,7 @@
                 <a:solidFill>
                   <a:srgbClr val="FFFFFF"/>
                 </a:solidFill>
-                <a:latin typeface="Calibri"/>
+                <a:latin typeface="Red Hat Display"/>
               </a:rPr>
               <a:t>3</a:t>
             </a:r>
@@ -9579,9 +9579,9 @@
             <a:r>
               <a:rPr sz="1500" b="0" i="0">
                 <a:solidFill>
-                  <a:srgbClr val="1A2B3C"/>
-                </a:solidFill>
-                <a:latin typeface="Calibri"/>
+                  <a:srgbClr val="151515"/>
+                </a:solidFill>
+                <a:latin typeface="Red Hat Text"/>
               </a:rPr>
               <a:t>Three scopes, briefly</a:t>
             </a:r>
@@ -9603,7 +9603,7 @@
             <a:avLst/>
           </a:prstGeom>
           <a:solidFill>
-            <a:srgbClr val="27AE60"/>
+            <a:srgbClr val="006E6E"/>
           </a:solidFill>
           <a:ln>
             <a:noFill/>
@@ -9659,7 +9659,7 @@
                 <a:solidFill>
                   <a:srgbClr val="FFFFFF"/>
                 </a:solidFill>
-                <a:latin typeface="Calibri"/>
+                <a:latin typeface="Red Hat Display"/>
               </a:rPr>
               <a:t>4</a:t>
             </a:r>
@@ -9692,9 +9692,9 @@
             <a:r>
               <a:rPr sz="1500" b="0" i="0">
                 <a:solidFill>
-                  <a:srgbClr val="1A2B3C"/>
-                </a:solidFill>
-                <a:latin typeface="Calibri"/>
+                  <a:srgbClr val="151515"/>
+                </a:solidFill>
+                <a:latin typeface="Red Hat Text"/>
               </a:rPr>
               <a:t>RAII: the mechanism</a:t>
             </a:r>
@@ -9716,7 +9716,7 @@
             <a:avLst/>
           </a:prstGeom>
           <a:solidFill>
-            <a:srgbClr val="00BCD4"/>
+            <a:srgbClr val="EE0000"/>
           </a:solidFill>
           <a:ln>
             <a:noFill/>
@@ -9772,7 +9772,7 @@
                 <a:solidFill>
                   <a:srgbClr val="FFFFFF"/>
                 </a:solidFill>
-                <a:latin typeface="Calibri"/>
+                <a:latin typeface="Red Hat Display"/>
               </a:rPr>
               <a:t>5</a:t>
             </a:r>
@@ -9805,9 +9805,9 @@
             <a:r>
               <a:rPr sz="1500" b="0" i="0">
                 <a:solidFill>
-                  <a:srgbClr val="1A2B3C"/>
-                </a:solidFill>
-                <a:latin typeface="Calibri"/>
+                  <a:srgbClr val="151515"/>
+                </a:solidFill>
+                <a:latin typeface="Red Hat Text"/>
               </a:rPr>
               <a:t>Where the compendium goes deeper</a:t>
             </a:r>
@@ -9855,7 +9855,7 @@
             <a:avLst/>
           </a:prstGeom>
           <a:solidFill>
-            <a:srgbClr val="1E6FC8"/>
+            <a:srgbClr val="EE0000"/>
           </a:solidFill>
           <a:ln>
             <a:noFill/>
@@ -9911,7 +9911,7 @@
                 <a:solidFill>
                   <a:srgbClr val="FFFFFF"/>
                 </a:solidFill>
-                <a:latin typeface="Calibri"/>
+                <a:latin typeface="Red Hat Display"/>
               </a:rPr>
               <a:t>Where the compendium goes deeper</a:t>
             </a:r>
@@ -9935,7 +9935,7 @@
             </a:avLst>
           </a:prstGeom>
           <a:solidFill>
-            <a:srgbClr val="1A2B3C"/>
+            <a:srgbClr val="151515"/>
           </a:solidFill>
           <a:ln>
             <a:noFill/>
@@ -9991,7 +9991,7 @@
                 <a:solidFill>
                   <a:srgbClr val="FFFFFF"/>
                 </a:solidFill>
-                <a:latin typeface="Calibri"/>
+                <a:latin typeface="Red Hat Display"/>
               </a:rPr>
               <a:t>§5</a:t>
             </a:r>
@@ -10024,11 +10024,11 @@
             <a:r>
               <a:rPr sz="1100" b="0" i="0">
                 <a:solidFill>
-                  <a:srgbClr val="90A4AE"/>
-                </a:solidFill>
-                <a:latin typeface="Calibri"/>
-              </a:rPr>
-              <a:t>Optimizing Modern C++ with Containers   |   Where the compendium goes deeper</a:t>
+                  <a:srgbClr val="8A8A8A"/>
+                </a:solidFill>
+                <a:latin typeface="Red Hat Text"/>
+              </a:rPr>
+              <a:t>Stateless C++ Services   |   Where the compendium goes deeper</a:t>
             </a:r>
           </a:p>
         </p:txBody>
@@ -10059,9 +10059,9 @@
             <a:r>
               <a:rPr sz="1100" b="0" i="0">
                 <a:solidFill>
-                  <a:srgbClr val="90A4AE"/>
-                </a:solidFill>
-                <a:latin typeface="Calibri"/>
+                  <a:srgbClr val="8A8A8A"/>
+                </a:solidFill>
+                <a:latin typeface="Red Hat Text"/>
               </a:rPr>
               <a:t>20 / 22</a:t>
             </a:r>
@@ -10094,9 +10094,9 @@
             <a:r>
               <a:rPr sz="2800" b="1" i="0">
                 <a:solidFill>
-                  <a:srgbClr val="1A2B3C"/>
-                </a:solidFill>
-                <a:latin typeface="Calibri"/>
+                  <a:srgbClr val="151515"/>
+                </a:solidFill>
+                <a:latin typeface="Red Hat Display"/>
               </a:rPr>
               <a:t>What's next, by concept</a:t>
             </a:r>
@@ -10135,7 +10135,7 @@
                 <a:solidFill>
                   <a:srgbClr val="00BCD4"/>
                 </a:solidFill>
-                <a:latin typeface="Calibri"/>
+                <a:latin typeface="Red Hat Text"/>
               </a:rPr>
               <a:t>The compendium, mapped to what we touched today</a:t>
             </a:r>
@@ -10151,7 +10151,7 @@
                 <a:solidFill>
                   <a:srgbClr val="1A2B3C"/>
                 </a:solidFill>
-                <a:latin typeface="Calibri"/>
+                <a:latin typeface="Red Hat Text"/>
               </a:rPr>
               <a:t>•  Request memory without per-request allocation — PMR arenas layered onto RAII</a:t>
             </a:r>
@@ -10167,7 +10167,7 @@
                 <a:solidFill>
                   <a:srgbClr val="1A2B3C"/>
                 </a:solidFill>
-                <a:latin typeface="Calibri"/>
+                <a:latin typeface="Red Hat Text"/>
               </a:rPr>
               <a:t>•  Process-scoped ownership done well — composition roots, dependency injection over singletons</a:t>
             </a:r>
@@ -10183,7 +10183,7 @@
                 <a:solidFill>
                   <a:srgbClr val="1A2B3C"/>
                 </a:solidFill>
-                <a:latin typeface="Calibri"/>
+                <a:latin typeface="Red Hat Text"/>
               </a:rPr>
               <a:t>•  Threading under a real CPU quota — why hardware_concurrency() lies to you in a container</a:t>
             </a:r>
@@ -10199,7 +10199,7 @@
                 <a:solidFill>
                   <a:srgbClr val="1A2B3C"/>
                 </a:solidFill>
-                <a:latin typeface="Calibri"/>
+                <a:latin typeface="Red Hat Text"/>
               </a:rPr>
               <a:t>•  Reaching external state safely — pooled connections, the outbox pattern, idempotency, deadlines</a:t>
             </a:r>
@@ -10215,7 +10215,7 @@
                 <a:solidFill>
                   <a:srgbClr val="1A2B3C"/>
                 </a:solidFill>
-                <a:latin typeface="Calibri"/>
+                <a:latin typeface="Red Hat Text"/>
               </a:rPr>
               <a:t>•  The ephemeral filesystem, health checks, graceful shutdown, and a full gRPC end-to-end example that composes all of it</a:t>
             </a:r>
@@ -10263,7 +10263,7 @@
             <a:avLst/>
           </a:prstGeom>
           <a:solidFill>
-            <a:srgbClr val="1E6FC8"/>
+            <a:srgbClr val="EE0000"/>
           </a:solidFill>
           <a:ln>
             <a:noFill/>
@@ -10319,7 +10319,7 @@
                 <a:solidFill>
                   <a:srgbClr val="FFFFFF"/>
                 </a:solidFill>
-                <a:latin typeface="Calibri"/>
+                <a:latin typeface="Red Hat Display"/>
               </a:rPr>
               <a:t>Where the compendium goes deeper</a:t>
             </a:r>
@@ -10343,7 +10343,7 @@
             </a:avLst>
           </a:prstGeom>
           <a:solidFill>
-            <a:srgbClr val="1A2B3C"/>
+            <a:srgbClr val="151515"/>
           </a:solidFill>
           <a:ln>
             <a:noFill/>
@@ -10399,7 +10399,7 @@
                 <a:solidFill>
                   <a:srgbClr val="FFFFFF"/>
                 </a:solidFill>
-                <a:latin typeface="Calibri"/>
+                <a:latin typeface="Red Hat Display"/>
               </a:rPr>
               <a:t>§5</a:t>
             </a:r>
@@ -10432,11 +10432,11 @@
             <a:r>
               <a:rPr sz="1100" b="0" i="0">
                 <a:solidFill>
-                  <a:srgbClr val="90A4AE"/>
-                </a:solidFill>
-                <a:latin typeface="Calibri"/>
-              </a:rPr>
-              <a:t>Optimizing Modern C++ with Containers   |   Where the compendium goes deeper</a:t>
+                  <a:srgbClr val="8A8A8A"/>
+                </a:solidFill>
+                <a:latin typeface="Red Hat Text"/>
+              </a:rPr>
+              <a:t>Stateless C++ Services   |   Where the compendium goes deeper</a:t>
             </a:r>
           </a:p>
         </p:txBody>
@@ -10467,9 +10467,9 @@
             <a:r>
               <a:rPr sz="1100" b="0" i="0">
                 <a:solidFill>
-                  <a:srgbClr val="90A4AE"/>
-                </a:solidFill>
-                <a:latin typeface="Calibri"/>
+                  <a:srgbClr val="8A8A8A"/>
+                </a:solidFill>
+                <a:latin typeface="Red Hat Text"/>
               </a:rPr>
               <a:t>21 / 22</a:t>
             </a:r>
@@ -10502,9 +10502,9 @@
             <a:r>
               <a:rPr sz="2800" b="1" i="0">
                 <a:solidFill>
-                  <a:srgbClr val="1A2B3C"/>
-                </a:solidFill>
-                <a:latin typeface="Calibri"/>
+                  <a:srgbClr val="151515"/>
+                </a:solidFill>
+                <a:latin typeface="Red Hat Display"/>
               </a:rPr>
               <a:t>If you remember one thing</a:t>
             </a:r>
@@ -10543,7 +10543,7 @@
                 <a:solidFill>
                   <a:srgbClr val="27AE60"/>
                 </a:solidFill>
-                <a:latin typeface="Calibri"/>
+                <a:latin typeface="Red Hat Text"/>
               </a:rPr>
               <a:t>Statelessness is earned, not declared</a:t>
             </a:r>
@@ -10559,7 +10559,7 @@
                 <a:solidFill>
                   <a:srgbClr val="1A2B3C"/>
                 </a:solidFill>
-                <a:latin typeface="Calibri"/>
+                <a:latin typeface="Red Hat Text"/>
               </a:rPr>
               <a:t>It's a deployment posture: a property of where a service keeps its data, not something you can read off the source code.</a:t>
             </a:r>
@@ -10578,7 +10578,7 @@
                 <a:solidFill>
                   <a:srgbClr val="1A2B3C"/>
                 </a:solidFill>
-                <a:latin typeface="Calibri"/>
+                <a:latin typeface="Red Hat Text"/>
               </a:rPr>
               <a:t>RAII is the C++ mechanism that makes the request-scope half of that posture enforceable rather than aspirational.</a:t>
             </a:r>
@@ -10597,7 +10597,7 @@
                 <a:solidFill>
                   <a:srgbClr val="1E6FC8"/>
                 </a:solidFill>
-                <a:latin typeface="Calibri"/>
+                <a:latin typeface="Red Hat Text"/>
               </a:rPr>
               <a:t>Everything else in the compendium is about getting the other two scopes — process and external — right.</a:t>
             </a:r>
@@ -10618,7 +10618,7 @@
     <p:bg>
       <p:bgPr>
         <a:solidFill>
-          <a:srgbClr val="1A2B3C"/>
+          <a:srgbClr val="151515"/>
         </a:solidFill>
         <a:effectLst/>
       </p:bgPr>
@@ -10658,7 +10658,7 @@
                 <a:solidFill>
                   <a:srgbClr val="FFFFFF"/>
                 </a:solidFill>
-                <a:latin typeface="Calibri"/>
+                <a:latin typeface="Red Hat Display"/>
               </a:rPr>
               <a:t>Now read the compendium.</a:t>
             </a:r>
@@ -10695,9 +10695,9 @@
             <a:r>
               <a:rPr sz="1800" b="0" i="0">
                 <a:solidFill>
-                  <a:srgbClr val="ECF0F1"/>
-                </a:solidFill>
-                <a:latin typeface="Calibri"/>
+                  <a:srgbClr val="F4F4F4"/>
+                </a:solidFill>
+                <a:latin typeface="Red Hat Text"/>
               </a:rPr>
               <a:t>Statelessness is earned by where a service keeps its data, not by how it's written.</a:t>
             </a:r>
@@ -10714,9 +10714,9 @@
             <a:r>
               <a:rPr sz="1800" b="0" i="0">
                 <a:solidFill>
-                  <a:srgbClr val="ECF0F1"/>
-                </a:solidFill>
-                <a:latin typeface="Calibri"/>
+                  <a:srgbClr val="F4F4F4"/>
+                </a:solidFill>
+                <a:latin typeface="Red Hat Text"/>
               </a:rPr>
               <a:t>RAII makes request scope enforceable. The compendium builds process scope and external state out just as far.</a:t>
             </a:r>
@@ -10733,11 +10733,11 @@
             <a:r>
               <a:rPr sz="1800" b="0" i="0">
                 <a:solidFill>
-                  <a:srgbClr val="27AE60"/>
-                </a:solidFill>
-                <a:latin typeface="Calibri"/>
-              </a:rPr>
-              <a:t>Eleven documents, every pattern with a runnable, host-verified Podman demo.</a:t>
+                  <a:srgbClr val="006E6E"/>
+                </a:solidFill>
+                <a:latin typeface="Red Hat Text"/>
+              </a:rPr>
+              <a:t>Eleven documents, every pattern with a runnable, host-verified Docker demo.</a:t>
             </a:r>
           </a:p>
         </p:txBody>
@@ -10768,9 +10768,9 @@
             <a:r>
               <a:rPr sz="1600" b="0" i="0">
                 <a:solidFill>
-                  <a:srgbClr val="90A4AE"/>
-                </a:solidFill>
-                <a:latin typeface="Calibri"/>
+                  <a:srgbClr val="8A8A8A"/>
+                </a:solidFill>
+                <a:latin typeface="Red Hat Text"/>
               </a:rPr>
               <a:t>Read the compendium  •  run the demos  •  the source is on the repo</a:t>
             </a:r>
@@ -10803,9 +10803,9 @@
             <a:r>
               <a:rPr sz="1100" b="0" i="0">
                 <a:solidFill>
-                  <a:srgbClr val="90A4AE"/>
-                </a:solidFill>
-                <a:latin typeface="Consolas"/>
+                  <a:srgbClr val="8A8A8A"/>
+                </a:solidFill>
+                <a:latin typeface="Red Hat Mono"/>
               </a:rPr>
               <a:t>github.com/patterncatalyst/cpp-statelessness</a:t>
             </a:r>
@@ -10826,7 +10826,7 @@
     <p:bg>
       <p:bgPr>
         <a:solidFill>
-          <a:srgbClr val="0A1628"/>
+          <a:srgbClr val="AB0000"/>
         </a:solidFill>
         <a:effectLst/>
       </p:bgPr>
@@ -10864,9 +10864,9 @@
             <a:r>
               <a:rPr sz="18000" b="1" i="0">
                 <a:solidFill>
-                  <a:srgbClr val="00BCD4"/>
-                </a:solidFill>
-                <a:latin typeface="Calibri"/>
+                  <a:srgbClr val="EE0000"/>
+                </a:solidFill>
+                <a:latin typeface="Red Hat Display"/>
               </a:rPr>
               <a:t>§1</a:t>
             </a:r>
@@ -10901,7 +10901,7 @@
                 <a:solidFill>
                   <a:srgbClr val="FFFFFF"/>
                 </a:solidFill>
-                <a:latin typeface="Calibri"/>
+                <a:latin typeface="Red Hat Display"/>
               </a:rPr>
               <a:t>Why statelessness matters for C++ services</a:t>
             </a:r>
@@ -10934,9 +10934,9 @@
             <a:r>
               <a:rPr sz="2000" b="0" i="1">
                 <a:solidFill>
-                  <a:srgbClr val="90A4AE"/>
-                </a:solidFill>
-                <a:latin typeface="Calibri"/>
+                  <a:srgbClr val="8A8A8A"/>
+                </a:solidFill>
+                <a:latin typeface="Red Hat Text"/>
               </a:rPr>
               <a:t>A process that forgets everything it doesn't need to remember is a process you can kill without fear.</a:t>
             </a:r>
@@ -10969,9 +10969,9 @@
             <a:r>
               <a:rPr sz="1100" b="0" i="0">
                 <a:solidFill>
-                  <a:srgbClr val="90A4AE"/>
-                </a:solidFill>
-                <a:latin typeface="Calibri"/>
+                  <a:srgbClr val="8A8A8A"/>
+                </a:solidFill>
+                <a:latin typeface="Red Hat Text"/>
               </a:rPr>
               <a:t>3 / 22</a:t>
             </a:r>
@@ -11019,7 +11019,7 @@
             <a:avLst/>
           </a:prstGeom>
           <a:solidFill>
-            <a:srgbClr val="1E6FC8"/>
+            <a:srgbClr val="EE0000"/>
           </a:solidFill>
           <a:ln>
             <a:noFill/>
@@ -11075,7 +11075,7 @@
                 <a:solidFill>
                   <a:srgbClr val="FFFFFF"/>
                 </a:solidFill>
-                <a:latin typeface="Calibri"/>
+                <a:latin typeface="Red Hat Display"/>
               </a:rPr>
               <a:t>Why statelessness matters for C++ services</a:t>
             </a:r>
@@ -11099,7 +11099,7 @@
             </a:avLst>
           </a:prstGeom>
           <a:solidFill>
-            <a:srgbClr val="1A2B3C"/>
+            <a:srgbClr val="151515"/>
           </a:solidFill>
           <a:ln>
             <a:noFill/>
@@ -11155,7 +11155,7 @@
                 <a:solidFill>
                   <a:srgbClr val="FFFFFF"/>
                 </a:solidFill>
-                <a:latin typeface="Calibri"/>
+                <a:latin typeface="Red Hat Display"/>
               </a:rPr>
               <a:t>§1</a:t>
             </a:r>
@@ -11188,11 +11188,11 @@
             <a:r>
               <a:rPr sz="1100" b="0" i="0">
                 <a:solidFill>
-                  <a:srgbClr val="90A4AE"/>
-                </a:solidFill>
-                <a:latin typeface="Calibri"/>
-              </a:rPr>
-              <a:t>Optimizing Modern C++ with Containers   |   Why statelessness matters for C++ services</a:t>
+                  <a:srgbClr val="8A8A8A"/>
+                </a:solidFill>
+                <a:latin typeface="Red Hat Text"/>
+              </a:rPr>
+              <a:t>Stateless C++ Services   |   Why statelessness matters for C++ services</a:t>
             </a:r>
           </a:p>
         </p:txBody>
@@ -11223,9 +11223,9 @@
             <a:r>
               <a:rPr sz="1100" b="0" i="0">
                 <a:solidFill>
-                  <a:srgbClr val="90A4AE"/>
-                </a:solidFill>
-                <a:latin typeface="Calibri"/>
+                  <a:srgbClr val="8A8A8A"/>
+                </a:solidFill>
+                <a:latin typeface="Red Hat Text"/>
               </a:rPr>
               <a:t>4 / 22</a:t>
             </a:r>
@@ -11258,9 +11258,9 @@
             <a:r>
               <a:rPr sz="2800" b="1" i="0">
                 <a:solidFill>
-                  <a:srgbClr val="1A2B3C"/>
-                </a:solidFill>
-                <a:latin typeface="Calibri"/>
+                  <a:srgbClr val="151515"/>
+                </a:solidFill>
+                <a:latin typeface="Red Hat Display"/>
               </a:rPr>
               <a:t>The problem with a service that remembers</a:t>
             </a:r>
@@ -11299,7 +11299,7 @@
                 <a:solidFill>
                   <a:srgbClr val="E84855"/>
                 </a:solidFill>
-                <a:latin typeface="Calibri"/>
+                <a:latin typeface="Red Hat Text"/>
               </a:rPr>
               <a:t>State creeps in quietly</a:t>
             </a:r>
@@ -11315,7 +11315,7 @@
                 <a:solidFill>
                   <a:srgbClr val="1A2B3C"/>
                 </a:solidFill>
-                <a:latin typeface="Calibri"/>
+                <a:latin typeface="Red Hat Text"/>
               </a:rPr>
               <a:t>•  An in-memory cache keyed by session, filled the first time a user shows up</a:t>
             </a:r>
@@ -11331,7 +11331,7 @@
                 <a:solidFill>
                   <a:srgbClr val="1A2B3C"/>
                 </a:solidFill>
-                <a:latin typeface="Calibri"/>
+                <a:latin typeface="Red Hat Text"/>
               </a:rPr>
               <a:t>•  A counter or rate limiter that assumes it has seen every prior request</a:t>
             </a:r>
@@ -11347,7 +11347,7 @@
                 <a:solidFill>
                   <a:srgbClr val="1A2B3C"/>
                 </a:solidFill>
-                <a:latin typeface="Calibri"/>
+                <a:latin typeface="Red Hat Text"/>
               </a:rPr>
               <a:t>•  A background thread that opened a file on startup and never checks if it's still there</a:t>
             </a:r>
@@ -11363,7 +11363,7 @@
                 <a:solidFill>
                   <a:srgbClr val="90A4AE"/>
                 </a:solidFill>
-                <a:latin typeface="Calibri"/>
+                <a:latin typeface="Red Hat Text"/>
               </a:rPr>
               <a:t>None of this looks dangerous in a single-process test. Every one of these becomes a bug the moment there's more than one copy of the process, or the process restarts mid-shift.</a:t>
             </a:r>
@@ -11411,7 +11411,7 @@
             <a:avLst/>
           </a:prstGeom>
           <a:solidFill>
-            <a:srgbClr val="1E6FC8"/>
+            <a:srgbClr val="EE0000"/>
           </a:solidFill>
           <a:ln>
             <a:noFill/>
@@ -11467,7 +11467,7 @@
                 <a:solidFill>
                   <a:srgbClr val="FFFFFF"/>
                 </a:solidFill>
-                <a:latin typeface="Calibri"/>
+                <a:latin typeface="Red Hat Display"/>
               </a:rPr>
               <a:t>Why statelessness matters for C++ services</a:t>
             </a:r>
@@ -11491,7 +11491,7 @@
             </a:avLst>
           </a:prstGeom>
           <a:solidFill>
-            <a:srgbClr val="1A2B3C"/>
+            <a:srgbClr val="151515"/>
           </a:solidFill>
           <a:ln>
             <a:noFill/>
@@ -11547,7 +11547,7 @@
                 <a:solidFill>
                   <a:srgbClr val="FFFFFF"/>
                 </a:solidFill>
-                <a:latin typeface="Calibri"/>
+                <a:latin typeface="Red Hat Display"/>
               </a:rPr>
               <a:t>§1</a:t>
             </a:r>
@@ -11580,11 +11580,11 @@
             <a:r>
               <a:rPr sz="1100" b="0" i="0">
                 <a:solidFill>
-                  <a:srgbClr val="90A4AE"/>
-                </a:solidFill>
-                <a:latin typeface="Calibri"/>
-              </a:rPr>
-              <a:t>Optimizing Modern C++ with Containers   |   Why statelessness matters for C++ services</a:t>
+                  <a:srgbClr val="8A8A8A"/>
+                </a:solidFill>
+                <a:latin typeface="Red Hat Text"/>
+              </a:rPr>
+              <a:t>Stateless C++ Services   |   Why statelessness matters for C++ services</a:t>
             </a:r>
           </a:p>
         </p:txBody>
@@ -11615,9 +11615,9 @@
             <a:r>
               <a:rPr sz="1100" b="0" i="0">
                 <a:solidFill>
-                  <a:srgbClr val="90A4AE"/>
-                </a:solidFill>
-                <a:latin typeface="Calibri"/>
+                  <a:srgbClr val="8A8A8A"/>
+                </a:solidFill>
+                <a:latin typeface="Red Hat Text"/>
               </a:rPr>
               <a:t>5 / 22</a:t>
             </a:r>
@@ -11650,9 +11650,9 @@
             <a:r>
               <a:rPr sz="2800" b="1" i="0">
                 <a:solidFill>
-                  <a:srgbClr val="1A2B3C"/>
-                </a:solidFill>
-                <a:latin typeface="Calibri"/>
+                  <a:srgbClr val="151515"/>
+                </a:solidFill>
+                <a:latin typeface="Red Hat Display"/>
               </a:rPr>
               <a:t>What changes under an orchestrator</a:t>
             </a:r>
@@ -11691,7 +11691,7 @@
                 <a:solidFill>
                   <a:srgbClr val="1E6FC8"/>
                 </a:solidFill>
-                <a:latin typeface="Calibri"/>
+                <a:latin typeface="Red Hat Text"/>
               </a:rPr>
               <a:t>The assumptions a dedicated box lets you get away with</a:t>
             </a:r>
@@ -11707,7 +11707,7 @@
                 <a:solidFill>
                   <a:srgbClr val="1A2B3C"/>
                 </a:solidFill>
-                <a:latin typeface="Calibri"/>
+                <a:latin typeface="Red Hat Text"/>
               </a:rPr>
               <a:t>•  Processes are disposable — the orchestrator restarts them routinely, not just on crash</a:t>
             </a:r>
@@ -11723,7 +11723,7 @@
                 <a:solidFill>
                   <a:srgbClr val="1A2B3C"/>
                 </a:solidFill>
-                <a:latin typeface="Calibri"/>
+                <a:latin typeface="Red Hat Text"/>
               </a:rPr>
               <a:t>•  Replicas come and go — scaling up or down changes which processes exist, mid-traffic</a:t>
             </a:r>
@@ -11739,7 +11739,7 @@
                 <a:solidFill>
                   <a:srgbClr val="1A2B3C"/>
                 </a:solidFill>
-                <a:latin typeface="Calibri"/>
+                <a:latin typeface="Red Hat Text"/>
               </a:rPr>
               <a:t>•  There is no "the same instance" — a load balancer has no memory of who it talked to last</a:t>
             </a:r>
@@ -11755,7 +11755,7 @@
                 <a:solidFill>
                   <a:srgbClr val="90A4AE"/>
                 </a:solidFill>
-                <a:latin typeface="Calibri"/>
+                <a:latin typeface="Red Hat Text"/>
               </a:rPr>
               <a:t>A habit that's harmless with one long-lived process becomes a correctness bug across N short-lived, interchangeable ones.</a:t>
             </a:r>
@@ -11803,7 +11803,7 @@
             <a:avLst/>
           </a:prstGeom>
           <a:solidFill>
-            <a:srgbClr val="1E6FC8"/>
+            <a:srgbClr val="EE0000"/>
           </a:solidFill>
           <a:ln>
             <a:noFill/>
@@ -11859,7 +11859,7 @@
                 <a:solidFill>
                   <a:srgbClr val="FFFFFF"/>
                 </a:solidFill>
-                <a:latin typeface="Calibri"/>
+                <a:latin typeface="Red Hat Display"/>
               </a:rPr>
               <a:t>Why statelessness matters for C++ services</a:t>
             </a:r>
@@ -11883,7 +11883,7 @@
             </a:avLst>
           </a:prstGeom>
           <a:solidFill>
-            <a:srgbClr val="1A2B3C"/>
+            <a:srgbClr val="151515"/>
           </a:solidFill>
           <a:ln>
             <a:noFill/>
@@ -11939,7 +11939,7 @@
                 <a:solidFill>
                   <a:srgbClr val="FFFFFF"/>
                 </a:solidFill>
-                <a:latin typeface="Calibri"/>
+                <a:latin typeface="Red Hat Display"/>
               </a:rPr>
               <a:t>§1</a:t>
             </a:r>
@@ -11972,11 +11972,11 @@
             <a:r>
               <a:rPr sz="1100" b="0" i="0">
                 <a:solidFill>
-                  <a:srgbClr val="90A4AE"/>
-                </a:solidFill>
-                <a:latin typeface="Calibri"/>
-              </a:rPr>
-              <a:t>Optimizing Modern C++ with Containers   |   Why statelessness matters for C++ services</a:t>
+                  <a:srgbClr val="8A8A8A"/>
+                </a:solidFill>
+                <a:latin typeface="Red Hat Text"/>
+              </a:rPr>
+              <a:t>Stateless C++ Services   |   Why statelessness matters for C++ services</a:t>
             </a:r>
           </a:p>
         </p:txBody>
@@ -12007,9 +12007,9 @@
             <a:r>
               <a:rPr sz="1100" b="0" i="0">
                 <a:solidFill>
-                  <a:srgbClr val="90A4AE"/>
-                </a:solidFill>
-                <a:latin typeface="Calibri"/>
+                  <a:srgbClr val="8A8A8A"/>
+                </a:solidFill>
+                <a:latin typeface="Red Hat Text"/>
               </a:rPr>
               <a:t>6 / 22</a:t>
             </a:r>
@@ -12042,9 +12042,9 @@
             <a:r>
               <a:rPr sz="2800" b="1" i="0">
                 <a:solidFill>
-                  <a:srgbClr val="1A2B3C"/>
-                </a:solidFill>
-                <a:latin typeface="Calibri"/>
+                  <a:srgbClr val="151515"/>
+                </a:solidFill>
+                <a:latin typeface="Red Hat Display"/>
               </a:rPr>
               <a:t>Four things worth memorizing before we go further</a:t>
             </a:r>
@@ -12066,7 +12066,7 @@
             <a:avLst/>
           </a:prstGeom>
           <a:solidFill>
-            <a:srgbClr val="E0E8F0"/>
+            <a:srgbClr val="D2D2D2"/>
           </a:solidFill>
           <a:ln>
             <a:noFill/>
@@ -12122,7 +12122,7 @@
                 <a:solidFill>
                   <a:srgbClr val="1E6FC8"/>
                 </a:solidFill>
-                <a:latin typeface="Calibri"/>
+                <a:latin typeface="Red Hat Display"/>
               </a:rPr>
               <a:t>Any</a:t>
             </a:r>
@@ -12155,9 +12155,9 @@
             <a:r>
               <a:rPr sz="1400" b="0" i="0">
                 <a:solidFill>
-                  <a:srgbClr val="1A2B3C"/>
-                </a:solidFill>
-                <a:latin typeface="Calibri"/>
+                  <a:srgbClr val="151515"/>
+                </a:solidFill>
+                <a:latin typeface="Red Hat Text"/>
               </a:rPr>
               <a:t>replica should be able to answer any request —
 none of them are special</a:t>
@@ -12180,7 +12180,7 @@
             <a:avLst/>
           </a:prstGeom>
           <a:solidFill>
-            <a:srgbClr val="E0E8F0"/>
+            <a:srgbClr val="D2D2D2"/>
           </a:solidFill>
           <a:ln>
             <a:noFill/>
@@ -12236,7 +12236,7 @@
                 <a:solidFill>
                   <a:srgbClr val="27AE60"/>
                 </a:solidFill>
-                <a:latin typeface="Calibri"/>
+                <a:latin typeface="Red Hat Display"/>
               </a:rPr>
               <a:t>0</a:t>
             </a:r>
@@ -12269,9 +12269,9 @@
             <a:r>
               <a:rPr sz="1400" b="0" i="0">
                 <a:solidFill>
-                  <a:srgbClr val="1A2B3C"/>
-                </a:solidFill>
-                <a:latin typeface="Calibri"/>
+                  <a:srgbClr val="151515"/>
+                </a:solidFill>
+                <a:latin typeface="Red Hat Text"/>
               </a:rPr>
               <a:t>coordination required between replicas before the
 orchestrator kills one of them</a:t>
@@ -12294,7 +12294,7 @@
             <a:avLst/>
           </a:prstGeom>
           <a:solidFill>
-            <a:srgbClr val="E0E8F0"/>
+            <a:srgbClr val="D2D2D2"/>
           </a:solidFill>
           <a:ln>
             <a:noFill/>
@@ -12350,7 +12350,7 @@
                 <a:solidFill>
                   <a:srgbClr val="00BCD4"/>
                 </a:solidFill>
-                <a:latin typeface="Calibri"/>
+                <a:latin typeface="Red Hat Display"/>
               </a:rPr>
               <a:t>Routine</a:t>
             </a:r>
@@ -12383,9 +12383,9 @@
             <a:r>
               <a:rPr sz="1400" b="0" i="0">
                 <a:solidFill>
-                  <a:srgbClr val="1A2B3C"/>
-                </a:solidFill>
-                <a:latin typeface="Calibri"/>
+                  <a:srgbClr val="151515"/>
+                </a:solidFill>
+                <a:latin typeface="Red Hat Text"/>
               </a:rPr>
               <a:t>restarts are, under an orchestrator — not
 incidents, not exceptional</a:t>
@@ -12408,7 +12408,7 @@
             <a:avLst/>
           </a:prstGeom>
           <a:solidFill>
-            <a:srgbClr val="E0E8F0"/>
+            <a:srgbClr val="D2D2D2"/>
           </a:solidFill>
           <a:ln>
             <a:noFill/>
@@ -12464,7 +12464,7 @@
                 <a:solidFill>
                   <a:srgbClr val="9B59B6"/>
                 </a:solidFill>
-                <a:latin typeface="Calibri"/>
+                <a:latin typeface="Red Hat Display"/>
               </a:rPr>
               <a:t>1</a:t>
             </a:r>
@@ -12497,9 +12497,9 @@
             <a:r>
               <a:rPr sz="1400" b="0" i="0">
                 <a:solidFill>
-                  <a:srgbClr val="1A2B3C"/>
-                </a:solidFill>
-                <a:latin typeface="Calibri"/>
+                  <a:srgbClr val="151515"/>
+                </a:solidFill>
+                <a:latin typeface="Red Hat Text"/>
               </a:rPr>
               <a:t>binary — stateless or not depends on what it
 holds and where, not how it's written</a:t>
@@ -12521,7 +12521,7 @@
     <p:bg>
       <p:bgPr>
         <a:solidFill>
-          <a:srgbClr val="0A1628"/>
+          <a:srgbClr val="AB0000"/>
         </a:solidFill>
         <a:effectLst/>
       </p:bgPr>
@@ -12559,9 +12559,9 @@
             <a:r>
               <a:rPr sz="18000" b="1" i="0">
                 <a:solidFill>
-                  <a:srgbClr val="00BCD4"/>
-                </a:solidFill>
-                <a:latin typeface="Calibri"/>
+                  <a:srgbClr val="EE0000"/>
+                </a:solidFill>
+                <a:latin typeface="Red Hat Display"/>
               </a:rPr>
               <a:t>§2</a:t>
             </a:r>
@@ -12596,7 +12596,7 @@
                 <a:solidFill>
                   <a:srgbClr val="FFFFFF"/>
                 </a:solidFill>
-                <a:latin typeface="Calibri"/>
+                <a:latin typeface="Red Hat Display"/>
               </a:rPr>
               <a:t>Stateless deployment posture: kill, replace, replicate</a:t>
             </a:r>
@@ -12629,9 +12629,9 @@
             <a:r>
               <a:rPr sz="2000" b="0" i="1">
                 <a:solidFill>
-                  <a:srgbClr val="90A4AE"/>
-                </a:solidFill>
-                <a:latin typeface="Calibri"/>
+                  <a:srgbClr val="8A8A8A"/>
+                </a:solidFill>
+                <a:latin typeface="Red Hat Text"/>
               </a:rPr>
               <a:t>The orchestrator's three verbs, and what each one assumes about your process.</a:t>
             </a:r>
@@ -12664,9 +12664,9 @@
             <a:r>
               <a:rPr sz="1100" b="0" i="0">
                 <a:solidFill>
-                  <a:srgbClr val="90A4AE"/>
-                </a:solidFill>
-                <a:latin typeface="Calibri"/>
+                  <a:srgbClr val="8A8A8A"/>
+                </a:solidFill>
+                <a:latin typeface="Red Hat Text"/>
               </a:rPr>
               <a:t>7 / 22</a:t>
             </a:r>
@@ -12714,7 +12714,7 @@
             <a:avLst/>
           </a:prstGeom>
           <a:solidFill>
-            <a:srgbClr val="1E6FC8"/>
+            <a:srgbClr val="EE0000"/>
           </a:solidFill>
           <a:ln>
             <a:noFill/>
@@ -12770,7 +12770,7 @@
                 <a:solidFill>
                   <a:srgbClr val="FFFFFF"/>
                 </a:solidFill>
-                <a:latin typeface="Calibri"/>
+                <a:latin typeface="Red Hat Display"/>
               </a:rPr>
               <a:t>Stateless deployment posture: kill, replace, replicate</a:t>
             </a:r>
@@ -12794,7 +12794,7 @@
             </a:avLst>
           </a:prstGeom>
           <a:solidFill>
-            <a:srgbClr val="1A2B3C"/>
+            <a:srgbClr val="151515"/>
           </a:solidFill>
           <a:ln>
             <a:noFill/>
@@ -12850,7 +12850,7 @@
                 <a:solidFill>
                   <a:srgbClr val="FFFFFF"/>
                 </a:solidFill>
-                <a:latin typeface="Calibri"/>
+                <a:latin typeface="Red Hat Display"/>
               </a:rPr>
               <a:t>§2</a:t>
             </a:r>
@@ -12883,11 +12883,11 @@
             <a:r>
               <a:rPr sz="1100" b="0" i="0">
                 <a:solidFill>
-                  <a:srgbClr val="90A4AE"/>
-                </a:solidFill>
-                <a:latin typeface="Calibri"/>
-              </a:rPr>
-              <a:t>Optimizing Modern C++ with Containers   |   Stateless deployment posture: kill, replace, replicate</a:t>
+                  <a:srgbClr val="8A8A8A"/>
+                </a:solidFill>
+                <a:latin typeface="Red Hat Text"/>
+              </a:rPr>
+              <a:t>Stateless C++ Services   |   Stateless deployment posture: kill, replace, replicate</a:t>
             </a:r>
           </a:p>
         </p:txBody>
@@ -12918,9 +12918,9 @@
             <a:r>
               <a:rPr sz="1100" b="0" i="0">
                 <a:solidFill>
-                  <a:srgbClr val="90A4AE"/>
-                </a:solidFill>
-                <a:latin typeface="Calibri"/>
+                  <a:srgbClr val="8A8A8A"/>
+                </a:solidFill>
+                <a:latin typeface="Red Hat Text"/>
               </a:rPr>
               <a:t>8 / 22</a:t>
             </a:r>
@@ -12953,9 +12953,9 @@
             <a:r>
               <a:rPr sz="2800" b="1" i="0">
                 <a:solidFill>
-                  <a:srgbClr val="1A2B3C"/>
-                </a:solidFill>
-                <a:latin typeface="Calibri"/>
+                  <a:srgbClr val="151515"/>
+                </a:solidFill>
+                <a:latin typeface="Red Hat Display"/>
               </a:rPr>
               <a:t>Kill</a:t>
             </a:r>
@@ -12994,7 +12994,7 @@
                 <a:solidFill>
                   <a:srgbClr val="E84855"/>
                 </a:solidFill>
-                <a:latin typeface="Calibri"/>
+                <a:latin typeface="Red Hat Text"/>
               </a:rPr>
               <a:t>The orchestrator can end your process at any time</a:t>
             </a:r>
@@ -13010,7 +13010,7 @@
                 <a:solidFill>
                   <a:srgbClr val="1A2B3C"/>
                 </a:solidFill>
-                <a:latin typeface="Calibri"/>
+                <a:latin typeface="Red Hat Text"/>
               </a:rPr>
               <a:t>•  A node needs to drain, a rolling update starts, the autoscaler decides to shrink</a:t>
             </a:r>
@@ -13026,7 +13026,7 @@
                 <a:solidFill>
                   <a:srgbClr val="1A2B3C"/>
                 </a:solidFill>
-                <a:latin typeface="Calibri"/>
+                <a:latin typeface="Red Hat Text"/>
               </a:rPr>
               <a:t>•  Your process gets a termination signal, and after a grace period, no signal at all</a:t>
             </a:r>
@@ -13042,7 +13042,7 @@
                 <a:solidFill>
                   <a:srgbClr val="1A2B3C"/>
                 </a:solidFill>
-                <a:latin typeface="Calibri"/>
+                <a:latin typeface="Red Hat Text"/>
               </a:rPr>
               <a:t>•  It does not negotiate: it does not wait for your in-flight state to be safe first</a:t>
             </a:r>
@@ -13058,7 +13058,7 @@
                 <a:solidFill>
                   <a:srgbClr val="90A4AE"/>
                 </a:solidFill>
-                <a:latin typeface="Calibri"/>
+                <a:latin typeface="Red Hat Text"/>
               </a:rPr>
               <a:t>The design requirement this creates: whatever happens, nothing authoritative can be lost when the process simply stops.</a:t>
             </a:r>
@@ -13106,7 +13106,7 @@
             <a:avLst/>
           </a:prstGeom>
           <a:solidFill>
-            <a:srgbClr val="1E6FC8"/>
+            <a:srgbClr val="EE0000"/>
           </a:solidFill>
           <a:ln>
             <a:noFill/>
@@ -13162,7 +13162,7 @@
                 <a:solidFill>
                   <a:srgbClr val="FFFFFF"/>
                 </a:solidFill>
-                <a:latin typeface="Calibri"/>
+                <a:latin typeface="Red Hat Display"/>
               </a:rPr>
               <a:t>Stateless deployment posture: kill, replace, replicate</a:t>
             </a:r>
@@ -13186,7 +13186,7 @@
             </a:avLst>
           </a:prstGeom>
           <a:solidFill>
-            <a:srgbClr val="1A2B3C"/>
+            <a:srgbClr val="151515"/>
           </a:solidFill>
           <a:ln>
             <a:noFill/>
@@ -13242,7 +13242,7 @@
                 <a:solidFill>
                   <a:srgbClr val="FFFFFF"/>
                 </a:solidFill>
-                <a:latin typeface="Calibri"/>
+                <a:latin typeface="Red Hat Display"/>
               </a:rPr>
               <a:t>§2</a:t>
             </a:r>
@@ -13275,11 +13275,11 @@
             <a:r>
               <a:rPr sz="1100" b="0" i="0">
                 <a:solidFill>
-                  <a:srgbClr val="90A4AE"/>
-                </a:solidFill>
-                <a:latin typeface="Calibri"/>
-              </a:rPr>
-              <a:t>Optimizing Modern C++ with Containers   |   Stateless deployment posture: kill, replace, replicate</a:t>
+                  <a:srgbClr val="8A8A8A"/>
+                </a:solidFill>
+                <a:latin typeface="Red Hat Text"/>
+              </a:rPr>
+              <a:t>Stateless C++ Services   |   Stateless deployment posture: kill, replace, replicate</a:t>
             </a:r>
           </a:p>
         </p:txBody>
@@ -13310,9 +13310,9 @@
             <a:r>
               <a:rPr sz="1100" b="0" i="0">
                 <a:solidFill>
-                  <a:srgbClr val="90A4AE"/>
-                </a:solidFill>
-                <a:latin typeface="Calibri"/>
+                  <a:srgbClr val="8A8A8A"/>
+                </a:solidFill>
+                <a:latin typeface="Red Hat Text"/>
               </a:rPr>
               <a:t>9 / 22</a:t>
             </a:r>
@@ -13345,9 +13345,9 @@
             <a:r>
               <a:rPr sz="2800" b="1" i="0">
                 <a:solidFill>
-                  <a:srgbClr val="1A2B3C"/>
-                </a:solidFill>
-                <a:latin typeface="Calibri"/>
+                  <a:srgbClr val="151515"/>
+                </a:solidFill>
+                <a:latin typeface="Red Hat Display"/>
               </a:rPr>
               <a:t>Replace</a:t>
             </a:r>
@@ -13386,7 +13386,7 @@
                 <a:solidFill>
                   <a:srgbClr val="F5A623"/>
                 </a:solidFill>
-                <a:latin typeface="Calibri"/>
+                <a:latin typeface="Red Hat Text"/>
               </a:rPr>
               <a:t>A new replica starts from the same image, from zero</a:t>
             </a:r>
@@ -13402,7 +13402,7 @@
                 <a:solidFill>
                   <a:srgbClr val="1A2B3C"/>
                 </a:solidFill>
-                <a:latin typeface="Calibri"/>
+                <a:latin typeface="Red Hat Text"/>
               </a:rPr>
               <a:t>•  It does not inherit anything the dead replica was holding in memory</a:t>
             </a:r>
@@ -13418,7 +13418,7 @@
                 <a:solidFill>
                   <a:srgbClr val="1A2B3C"/>
                 </a:solidFill>
-                <a:latin typeface="Calibri"/>
+                <a:latin typeface="Red Hat Text"/>
               </a:rPr>
               <a:t>•  Startup has to be fast and self-sufficient — no dependency on the old process's state</a:t>
             </a:r>
@@ -13434,7 +13434,7 @@
                 <a:solidFill>
                   <a:srgbClr val="1A2B3C"/>
                 </a:solidFill>
-                <a:latin typeface="Calibri"/>
+                <a:latin typeface="Red Hat Text"/>
               </a:rPr>
               <a:t>•  Anything the new replica needs, it has to be able to rebuild or fetch on its own</a:t>
             </a:r>
@@ -13450,7 +13450,7 @@
                 <a:solidFill>
                   <a:srgbClr val="90A4AE"/>
                 </a:solidFill>
-                <a:latin typeface="Calibri"/>
+                <a:latin typeface="Red Hat Text"/>
               </a:rPr>
               <a:t>This is where "process scope" earns its name: state it's fine to rebuild from scratch every time the process starts.</a:t>
             </a:r>

</xml_diff>